<commit_message>
Sourced deck: new research-response and lens wording on pages 2-3
Co-Authored-By: Claude Opus 5.5 <noreply@anthropic.com>
Claude-Session: https://claude.ai/code/session_0198bm9pfzRwgZQBqNvd56W8
</commit_message>
<xml_diff>
--- a/deck/Optum-LS-Conversational-AI-sourced.pptx
+++ b/deck/Optum-LS-Conversational-AI-sourced.pptx
@@ -8469,6 +8469,10 @@
             </a:outerShdw>
           </a:effectLst>
         </p:spPr>
+        <p:txBody>
+          <a:bodyPr/>
+          <a:p/>
+        </p:txBody>
       </p:sp>
       <p:sp>
         <p:nvSpPr>
@@ -8489,6 +8493,10 @@
           </a:solidFill>
           <a:ln/>
         </p:spPr>
+        <p:txBody>
+          <a:bodyPr/>
+          <a:p/>
+        </p:txBody>
       </p:sp>
       <p:pic>
         <p:nvPicPr>
@@ -8634,6 +8642,10 @@
             <a:prstDash val="solid"/>
           </a:ln>
         </p:spPr>
+        <p:txBody>
+          <a:bodyPr/>
+          <a:p/>
+        </p:txBody>
       </p:sp>
       <p:sp>
         <p:nvSpPr>
@@ -8697,6 +8709,10 @@
             <a:prstDash val="solid"/>
           </a:ln>
         </p:spPr>
+        <p:txBody>
+          <a:bodyPr/>
+          <a:p/>
+        </p:txBody>
       </p:sp>
       <p:sp>
         <p:nvSpPr>
@@ -8760,6 +8776,10 @@
             <a:prstDash val="solid"/>
           </a:ln>
         </p:spPr>
+        <p:txBody>
+          <a:bodyPr/>
+          <a:p/>
+        </p:txBody>
       </p:sp>
       <p:sp>
         <p:nvSpPr>
@@ -8823,6 +8843,10 @@
             <a:prstDash val="solid"/>
           </a:ln>
         </p:spPr>
+        <p:txBody>
+          <a:bodyPr/>
+          <a:p/>
+        </p:txBody>
       </p:sp>
       <p:sp>
         <p:nvSpPr>
@@ -8922,6 +8946,10 @@
             <a:prstDash val="solid"/>
           </a:ln>
         </p:spPr>
+        <p:txBody>
+          <a:bodyPr/>
+          <a:p/>
+        </p:txBody>
       </p:sp>
       <p:sp>
         <p:nvSpPr>
@@ -8989,7 +9017,7 @@
                   <a:schemeClr val="tx1"/>
                 </a:solidFill>
               </a:rPr>
-              <a:t>The U.S. competitive landscape is the primary focus; selected international offerings provide context; and Optum LS is the strategic reference point.</a:t>
+              <a:t>The U.S. is the primary competitive focus; selected international offerings provide context; Optum LS anchors the comparisons.</a:t>
             </a:r>
             <a:endParaRPr lang="en-US" sz="1100" dirty="0"/>
           </a:p>
@@ -9910,6 +9938,10 @@
             <a:prstDash val="solid"/>
           </a:ln>
         </p:spPr>
+        <p:txBody>
+          <a:bodyPr/>
+          <a:p/>
+        </p:txBody>
       </p:sp>
       <p:sp>
         <p:nvSpPr>
@@ -10007,6 +10039,10 @@
             <a:prstDash val="solid"/>
           </a:ln>
         </p:spPr>
+        <p:txBody>
+          <a:bodyPr/>
+          <a:p/>
+        </p:txBody>
       </p:sp>
       <p:sp>
         <p:nvSpPr>
@@ -10201,6 +10237,10 @@
             <a:prstDash val="solid"/>
           </a:ln>
         </p:spPr>
+        <p:txBody>
+          <a:bodyPr/>
+          <a:p/>
+        </p:txBody>
       </p:sp>
       <p:sp>
         <p:nvSpPr>
@@ -10356,6 +10396,10 @@
             <a:prstDash val="solid"/>
           </a:ln>
         </p:spPr>
+        <p:txBody>
+          <a:bodyPr/>
+          <a:p/>
+        </p:txBody>
       </p:sp>
       <p:sp>
         <p:nvSpPr>
@@ -10550,6 +10594,10 @@
             <a:prstDash val="solid"/>
           </a:ln>
         </p:spPr>
+        <p:txBody>
+          <a:bodyPr/>
+          <a:p/>
+        </p:txBody>
       </p:sp>
       <p:sp>
         <p:nvSpPr>
@@ -10674,6 +10722,10 @@
             </a:outerShdw>
           </a:effectLst>
         </p:spPr>
+        <p:txBody>
+          <a:bodyPr/>
+          <a:p/>
+        </p:txBody>
       </p:sp>
       <p:sp>
         <p:nvSpPr>
@@ -10773,6 +10825,10 @@
             </a:outerShdw>
           </a:effectLst>
         </p:spPr>
+        <p:txBody>
+          <a:bodyPr/>
+          <a:p/>
+        </p:txBody>
       </p:sp>
       <p:sp>
         <p:nvSpPr>
@@ -10840,7 +10896,7 @@
                   <a:schemeClr val="tx1"/>
                 </a:solidFill>
               </a:rPr>
-              <a:t>We look beyond RWE to assess publicly-marketed conversational AI across five Optum LS-aligned domains, prioritizing the U.S. competitive landscape and using selected international offerings for context.</a:t>
+              <a:t>We examine publicly marketed conversational AI across five Optum LS-relevant business domains. Vendors' product claims and descriptions of customer use provide observable evidence for comparing competitive positioning without access to internal product data.</a:t>
             </a:r>
             <a:endParaRPr lang="en-US" sz="1200" dirty="0"/>
           </a:p>

</xml_diff>

<commit_message>
Sourced deck: center hero figures, rebalance key takeaway, trim NEXT label
Co-Authored-By: Claude Opus 5.5 <noreply@anthropic.com>
Claude-Session: https://claude.ai/code/session_0198bm9pfzRwgZQBqNvd56W8
</commit_message>
<xml_diff>
--- a/deck/Optum-LS-Conversational-AI-sourced.pptx
+++ b/deck/Optum-LS-Conversational-AI-sourced.pptx
@@ -9049,6 +9049,10 @@
             </a:outerShdw>
           </a:effectLst>
         </p:spPr>
+        <p:txBody>
+          <a:bodyPr/>
+          <a:p/>
+        </p:txBody>
       </p:sp>
       <p:sp>
         <p:nvSpPr>
@@ -9069,6 +9073,10 @@
           </a:solidFill>
           <a:ln/>
         </p:spPr>
+        <p:txBody>
+          <a:bodyPr/>
+          <a:p/>
+        </p:txBody>
       </p:sp>
       <p:pic>
         <p:nvPicPr>
@@ -9151,7 +9159,7 @@
           <a:bodyPr wrap="square" lIns="0" tIns="0" rIns="0" bIns="0" rtlCol="0" anchor="t"/>
           <a:lstStyle/>
           <a:p>
-            <a:pPr indent="0" marL="0">
+            <a:pPr indent="0" marL="0" algn="ctr">
               <a:buNone/>
             </a:pPr>
             <a:r>
@@ -9268,6 +9276,10 @@
             <a:prstDash val="solid"/>
           </a:ln>
         </p:spPr>
+        <p:txBody>
+          <a:bodyPr/>
+          <a:p/>
+        </p:txBody>
       </p:sp>
       <p:sp>
         <p:nvSpPr>
@@ -9290,7 +9302,7 @@
           <a:bodyPr wrap="square" lIns="0" tIns="0" rIns="0" bIns="0" rtlCol="0" anchor="t"/>
           <a:lstStyle/>
           <a:p>
-            <a:pPr indent="0" marL="0">
+            <a:pPr indent="0" marL="0" algn="ctr">
               <a:buNone/>
             </a:pPr>
             <a:r>
@@ -9389,6 +9401,10 @@
             </a:outerShdw>
           </a:effectLst>
         </p:spPr>
+        <p:txBody>
+          <a:bodyPr/>
+          <a:p/>
+        </p:txBody>
       </p:sp>
       <p:sp>
         <p:nvSpPr>
@@ -9409,6 +9425,10 @@
           </a:solidFill>
           <a:ln/>
         </p:spPr>
+        <p:txBody>
+          <a:bodyPr/>
+          <a:p/>
+        </p:txBody>
       </p:sp>
       <p:pic>
         <p:nvPicPr>
@@ -9569,6 +9589,10 @@
             </a:outerShdw>
           </a:effectLst>
         </p:spPr>
+        <p:txBody>
+          <a:bodyPr/>
+          <a:p/>
+        </p:txBody>
       </p:sp>
       <p:sp>
         <p:nvSpPr>
@@ -9589,6 +9613,10 @@
           </a:solidFill>
           <a:ln/>
         </p:spPr>
+        <p:txBody>
+          <a:bodyPr/>
+          <a:p/>
+        </p:txBody>
       </p:sp>
       <p:pic>
         <p:nvPicPr>
@@ -12984,8 +13012,8 @@
         </p:nvSpPr>
         <p:spPr>
           <a:xfrm>
-            <a:off x="548640" y="5596128"/>
-            <a:ext cx="11091672" cy="548640"/>
+            <a:off x="1110996" y="5596128"/>
+            <a:ext cx="9966960" cy="548640"/>
           </a:xfrm>
           <a:prstGeom prst="rect">
             <a:avLst/>
@@ -13015,8 +13043,8 @@
         </p:nvSpPr>
         <p:spPr>
           <a:xfrm>
-            <a:off x="548640" y="5596128"/>
-            <a:ext cx="2377440" cy="548640"/>
+            <a:off x="1293876" y="5596128"/>
+            <a:ext cx="2011680" cy="548640"/>
           </a:xfrm>
           <a:prstGeom prst="rect">
             <a:avLst/>
@@ -13051,8 +13079,8 @@
         </p:nvSpPr>
         <p:spPr>
           <a:xfrm>
-            <a:off x="2926080" y="5596128"/>
-            <a:ext cx="8531352" cy="548640"/>
+            <a:off x="3305556" y="5596128"/>
+            <a:ext cx="7589520" cy="548640"/>
           </a:xfrm>
           <a:prstGeom prst="rect">
             <a:avLst/>
@@ -13064,7 +13092,7 @@
           <a:bodyPr wrap="square" lIns="0" tIns="0" rIns="0" bIns="0" rtlCol="0" anchor="ctr"/>
           <a:lstStyle/>
           <a:p>
-            <a:pPr indent="0" marL="0">
+            <a:pPr indent="0" marL="0" algn="ctr">
               <a:buNone/>
             </a:pPr>
             <a:r>
@@ -13073,12 +13101,12 @@
                   <a:schemeClr val="tx1"/>
                 </a:solidFill>
               </a:rPr>
-              <a:t>A publicly-marketed customer-facing conversational interface was not established in the reviewed materials for Optum LS</a:t>
+              <a:t>A publicly-marketed customer-facing conversational interface was not established in the reviewed materials</a:t>
             </a:r>
             <a:endParaRPr lang="en-US" sz="1050" dirty="0"/>
           </a:p>
           <a:p>
-            <a:pPr indent="0" marL="0">
+            <a:pPr indent="0" marL="0" algn="ctr">
               <a:buNone/>
             </a:pPr>
             <a:r>
@@ -13087,7 +13115,7 @@
                   <a:schemeClr val="tx1"/>
                 </a:solidFill>
               </a:rPr>
-              <a:t>across the five relevant business domains.</a:t>
+              <a:t>for Optum LS across the five relevant business domains.</a:t>
             </a:r>
             <a:endParaRPr lang="en-US" sz="1050" dirty="0"/>
           </a:p>
@@ -14541,6 +14569,10 @@
           </a:solidFill>
           <a:ln/>
         </p:spPr>
+        <p:txBody>
+          <a:bodyPr/>
+          <a:p/>
+        </p:txBody>
       </p:sp>
       <p:sp>
         <p:nvSpPr>
@@ -16519,6 +16551,10 @@
             </a:outerShdw>
           </a:effectLst>
         </p:spPr>
+        <p:txBody>
+          <a:bodyPr/>
+          <a:p/>
+        </p:txBody>
       </p:sp>
       <p:sp>
         <p:nvSpPr>
@@ -16618,6 +16654,10 @@
             </a:outerShdw>
           </a:effectLst>
         </p:spPr>
+        <p:txBody>
+          <a:bodyPr/>
+          <a:p/>
+        </p:txBody>
       </p:sp>
       <p:sp>
         <p:nvSpPr>
@@ -16638,6 +16678,10 @@
           </a:solidFill>
           <a:ln/>
         </p:spPr>
+        <p:txBody>
+          <a:bodyPr/>
+          <a:p/>
+        </p:txBody>
       </p:sp>
       <p:pic>
         <p:nvPicPr>
@@ -16693,7 +16737,7 @@
                   <a:schemeClr val="accent2"/>
                 </a:solidFill>
               </a:rPr>
-              <a:t>NEXT: FROM COMPANY SCREENS TO ACTUAL PRODUCTS</a:t>
+              <a:t>FROM COMPANY SCREENS TO ACTUAL PRODUCTS</a:t>
             </a:r>
             <a:endParaRPr lang="en-US" sz="1300" dirty="0"/>
           </a:p>

</xml_diff>

<commit_message>
Sourced deck: add linked LinkedIn and email contact line to cover
Co-Authored-By: Claude Opus 5.5 <noreply@anthropic.com>
Claude-Session: https://claude.ai/code/session_0198bm9pfzRwgZQBqNvd56W8
</commit_message>
<xml_diff>
--- a/deck/Optum-LS-Conversational-AI-sourced.pptx
+++ b/deck/Optum-LS-Conversational-AI-sourced.pptx
@@ -3571,6 +3571,61 @@
                 <a:latin typeface="Arial"/>
               </a:rPr>
               <a:t>Research and drafting were assisted by AI tools; the analysis and conclusions are the author’s own.</a:t>
+            </a:r>
+          </a:p>
+        </p:txBody>
+      </p:sp>
+      <p:sp>
+        <p:nvSpPr>
+          <p:cNvPr id="15" name="cover contact"/>
+          <p:cNvSpPr txBox="1"/>
+          <p:nvPr/>
+        </p:nvSpPr>
+        <p:spPr>
+          <a:xfrm>
+            <a:off x="822960" y="5138928"/>
+            <a:ext cx="8229600" cy="274320"/>
+          </a:xfrm>
+          <a:prstGeom prst="rect">
+            <a:avLst/>
+          </a:prstGeom>
+          <a:noFill/>
+        </p:spPr>
+        <p:txBody>
+          <a:bodyPr wrap="square" lIns="0" rIns="0" tIns="0" bIns="0">
+            <a:spAutoFit/>
+          </a:bodyPr>
+          <a:lstStyle/>
+          <a:p>
+            <a:pPr algn="l"/>
+            <a:r>
+              <a:rPr sz="1200" u="none">
+                <a:solidFill>
+                  <a:srgbClr val="002677"/>
+                </a:solidFill>
+                <a:latin typeface="Arial"/>
+                <a:hlinkClick r:id="rId2"/>
+              </a:rPr>
+              <a:t>linkedin.com/in/joseph-marino-995651183</a:t>
+            </a:r>
+            <a:r>
+              <a:rPr sz="1200">
+                <a:solidFill>
+                  <a:srgbClr val="7A7C7E"/>
+                </a:solidFill>
+                <a:latin typeface="Arial"/>
+              </a:rPr>
+              <a:t>  ·  </a:t>
+            </a:r>
+            <a:r>
+              <a:rPr sz="1200" u="none">
+                <a:solidFill>
+                  <a:srgbClr val="002677"/>
+                </a:solidFill>
+                <a:latin typeface="Arial"/>
+                <a:hlinkClick r:id="rId3"/>
+              </a:rPr>
+              <a:t>marinojoe@gmail.com</a:t>
             </a:r>
           </a:p>
         </p:txBody>

</xml_diff>

<commit_message>
Sourced deck: LLM-provider wording in notes, Norstella product, company framing, new key finding
Co-Authored-By: Claude Opus 5.5 <noreply@anthropic.com>
Claude-Session: https://claude.ai/code/session_0198bm9pfzRwgZQBqNvd56W8
</commit_message>
<xml_diff>
--- a/deck/Optum-LS-Conversational-AI-sourced.pptx
+++ b/deck/Optum-LS-Conversational-AI-sourced.pptx
@@ -7100,7 +7100,7 @@
                   <a:schemeClr val="tx1"/>
                 </a:solidFill>
               </a:rPr>
-              <a:t>Dates reflect selected public announcements or releases, not necessarily first feature availability. The timeline illustrates a research catalyst, not measured market-wide growth. AI-enabled or agentic launches are not automatically qualifying conversational products; the Norstella example is excluded from the final conversational count.</a:t>
+              <a:t>Dates reflect selected public announcements or releases, not necessarily first feature availability. The timeline illustrates a research catalyst, not measured market-wide growth. AI-enabled or agentic launches are not automatically qualifying conversational products; Norstella’s Atlas Patient Analytics is excluded from the final conversational count.</a:t>
             </a:r>
             <a:endParaRPr lang="en-US" sz="1000" dirty="0"/>
           </a:p>
@@ -8201,7 +8201,7 @@
                   <a:schemeClr val="tx1"/>
                 </a:solidFill>
               </a:rPr>
-              <a:t>These are selected publicly documented developments, not an exhaustive assessment of AI suppliers. The three approaches are neither mutually exclusive nor predictions of future competition. They do not establish that AI suppliers caused the recent RWE launch cluster, are displacing established vendors, or expose an Optum capability gap. Not all supplier offerings qualify as conversational products; they are not additions to the deck's product counts. North for Pharma was described as planned; Explore Assistant's general commercial availability was not established in our review.</a:t>
+              <a:t>These are selected publicly documented developments, not an exhaustive assessment of LLM providers. The three approaches are neither mutually exclusive nor predictions of future competition. They do not establish that LLM providers caused the recent RWE launch cluster, are displacing established vendors, or expose an Optum capability gap. Not all LLM provider offerings qualify as conversational products; they are not additions to the deck's product counts. North for Pharma was described as planned; Explore Assistant's general commercial availability was not established in our review.</a:t>
             </a:r>
             <a:endParaRPr lang="en-US" sz="1000" dirty="0"/>
           </a:p>
@@ -9396,35 +9396,43 @@
             <a:pPr indent="0" marL="0">
               <a:buNone/>
             </a:pPr>
+            <a:pPr indent="0" marL="0">
+              <a:buNone/>
+            </a:pPr>
+            <a:pPr indent="0" marL="0">
+              <a:buNone/>
+            </a:pPr>
+            <a:r>
+              <a:rPr lang="en-US" sz="1050" b="1" dirty="0">
+                <a:solidFill>
+                  <a:schemeClr val="tx1"/>
+                </a:solidFill>
+              </a:rPr>
+              <a:t>Nine selected international offerings</a:t>
+            </a:r>
             <a:r>
               <a:rPr lang="en-US" sz="1050" dirty="0">
                 <a:solidFill>
                   <a:schemeClr val="tx1"/>
                 </a:solidFill>
               </a:rPr>
-              <a:t>The selected international comparison identified </a:t>
-            </a:r>
-            <a:pPr indent="0" marL="0">
-              <a:buNone/>
-            </a:pPr>
+              <a:t> show how vendors outside the U.S. position conversational interaction, concentrated in </a:t>
+            </a:r>
             <a:r>
               <a:rPr lang="en-US" sz="1050" b="1" dirty="0">
                 <a:solidFill>
                   <a:schemeClr val="tx1"/>
                 </a:solidFill>
               </a:rPr>
-              <a:t>9 qualifying conversational AI offerings,</a:t>
-            </a:r>
-            <a:pPr indent="0" marL="0">
-              <a:buNone/>
-            </a:pPr>
+              <a:t>RWE and Commercial Intelligence</a:t>
+            </a:r>
             <a:r>
               <a:rPr lang="en-US" sz="1050" dirty="0">
                 <a:solidFill>
                   <a:schemeClr val="tx1"/>
                 </a:solidFill>
               </a:rPr>
-              <a:t> providing additional examples of how vendors position conversational interaction.</a:t>
+              <a:t>.</a:t>
             </a:r>
             <a:endParaRPr lang="en-US" sz="1050" dirty="0"/>
           </a:p>
@@ -14525,7 +14533,7 @@
                   <a:schemeClr val="accent2"/>
                 </a:solidFill>
               </a:rPr>
-              <a:t>U.S. BASELINE AND INTERNATIONAL COMPETITOR SCREENS</a:t>
+              <a:t>U.S. BASELINE AND INTERNATIONAL COMPANY SCREENS</a:t>
             </a:r>
             <a:endParaRPr lang="en-US" sz="1000" dirty="0"/>
           </a:p>
@@ -16677,7 +16685,7 @@
                   <a:schemeClr val="tx1"/>
                 </a:solidFill>
               </a:rPr>
-              <a:t>Each bar shows the share of comparable companies we screened that market conversational AI. International counts exclude competitors already represented in the U.S. inventory.</a:t>
+              <a:t>Each bar shows the share of comparable companies we screened that market conversational AI. International counts exclude companies already represented in the U.S. inventory.</a:t>
             </a:r>
             <a:endParaRPr lang="en-US" sz="1000" dirty="0"/>
           </a:p>

</xml_diff>

<commit_message>
Sourced deck: drop India note, label methodology notes by slide topic
Co-Authored-By: Claude Opus 5.5 <noreply@anthropic.com>
Claude-Session: https://claude.ai/code/session_0198bm9pfzRwgZQBqNvd56W8
</commit_message>
<xml_diff>
--- a/deck/Optum-LS-Conversational-AI-sourced.pptx
+++ b/deck/Optum-LS-Conversational-AI-sourced.pptx
@@ -6961,7 +6961,7 @@
                   <a:schemeClr val="accent2"/>
                 </a:solidFill>
               </a:rPr>
-              <a:t>SLIDE 2 — EVIDENCE BOUNDARY</a:t>
+              <a:t>SLIDE 2 — EXECUTIVE SUMMARY</a:t>
             </a:r>
             <a:endParaRPr lang="en-US" sz="1000" dirty="0"/>
           </a:p>
@@ -7064,7 +7064,7 @@
                   <a:schemeClr val="accent2"/>
                 </a:solidFill>
               </a:rPr>
-              <a:t>SLIDE 3 — EVIDENCE BOUNDARY</a:t>
+              <a:t>SLIDE 3 — RESEARCH CATALYST</a:t>
             </a:r>
             <a:endParaRPr lang="en-US" sz="1000" dirty="0"/>
           </a:p>
@@ -7167,7 +7167,7 @@
                   <a:schemeClr val="accent2"/>
                 </a:solidFill>
               </a:rPr>
-              <a:t>SLIDE 4 — METHODOLOGY NOTE</a:t>
+              <a:t>SLIDE 4 — U.S. LANDSCAPE</a:t>
             </a:r>
             <a:endParaRPr lang="en-US" sz="1000" dirty="0"/>
           </a:p>
@@ -7247,7 +7247,7 @@
       </p:sp>
       <p:sp>
         <p:nvSpPr>
-          <p:cNvPr id="12" name="slide 4 — india reconciliation"/>
+          <p:cNvPr id="15" name="slide 4 — evidence boundary"/>
           <p:cNvSpPr/>
           <p:nvPr/>
         </p:nvSpPr>
@@ -7278,7 +7278,7 @@
       </p:sp>
       <p:sp>
         <p:nvSpPr>
-          <p:cNvPr id="13" name="label"/>
+          <p:cNvPr id="16" name="label"/>
           <p:cNvSpPr txBox="1"/>
           <p:nvPr/>
         </p:nvSpPr>
@@ -7306,7 +7306,7 @@
                   <a:schemeClr val="accent2"/>
                 </a:solidFill>
               </a:rPr>
-              <a:t>SLIDE 5 — INDIA RECONCILIATION</a:t>
+              <a:t>SLIDE 5 — INTERNATIONAL SCREENS</a:t>
             </a:r>
             <a:endParaRPr lang="en-US" sz="1000" dirty="0"/>
           </a:p>
@@ -7314,7 +7314,7 @@
       </p:sp>
       <p:sp>
         <p:nvSpPr>
-          <p:cNvPr id="14" name="Text 12"/>
+          <p:cNvPr id="17" name="Text 15"/>
           <p:cNvSpPr txBox="1"/>
           <p:nvPr/>
         </p:nvSpPr>
@@ -7342,7 +7342,7 @@
                   <a:schemeClr val="tx1"/>
                 </a:solidFill>
               </a:rPr>
-              <a:t>Of 37 screened companies, 36 qualify as direct/specialized comparators in at least one of the five domains; excluding four companies already represented in the qualifying U.S. chat cohort leaves 32. Three additional chat-marketing companies qualify: Axtria, Doceree and Genpact. Company presence in an India screen does not prove the specific product is available or deployed in India.</a:t>
+              <a:t>Selected country/region screens differ in research depth and company composition and are not representative national market samples. The Nordics screen groups Denmark, Finland, Norway and Sweden. A multinational may appear in multiple country screens; the counts are not additive across countries. A globally marketed product does not establish locally verified use. Percentages show shares within screened comparable companies, not regional adoption, customer penetration or product deployment rates.</a:t>
             </a:r>
             <a:endParaRPr lang="en-US" sz="1000" dirty="0"/>
           </a:p>
@@ -7350,7 +7350,7 @@
       </p:sp>
       <p:sp>
         <p:nvSpPr>
-          <p:cNvPr id="15" name="slide 4 — evidence boundary"/>
+          <p:cNvPr id="18" name="slide 5 — evidence boundary"/>
           <p:cNvSpPr/>
           <p:nvPr/>
         </p:nvSpPr>
@@ -7381,7 +7381,7 @@
       </p:sp>
       <p:sp>
         <p:nvSpPr>
-          <p:cNvPr id="16" name="label"/>
+          <p:cNvPr id="19" name="label"/>
           <p:cNvSpPr txBox="1"/>
           <p:nvPr/>
         </p:nvSpPr>
@@ -7409,110 +7409,7 @@
                   <a:schemeClr val="accent2"/>
                 </a:solidFill>
               </a:rPr>
-              <a:t>SLIDE 5 — EVIDENCE BOUNDARY</a:t>
-            </a:r>
-            <a:endParaRPr lang="en-US" sz="1000" dirty="0"/>
-          </a:p>
-        </p:txBody>
-      </p:sp>
-      <p:sp>
-        <p:nvSpPr>
-          <p:cNvPr id="17" name="Text 15"/>
-          <p:cNvSpPr txBox="1"/>
-          <p:nvPr/>
-        </p:nvSpPr>
-        <p:spPr>
-          <a:xfrm>
-            <a:off x="4483608" y="3579876"/>
-            <a:ext cx="3221736" cy="1677924"/>
-          </a:xfrm>
-          <a:prstGeom prst="rect">
-            <a:avLst/>
-          </a:prstGeom>
-          <a:noFill/>
-          <a:ln/>
-        </p:spPr>
-        <p:txBody>
-          <a:bodyPr wrap="square" lIns="0" tIns="0" rIns="0" bIns="0" rtlCol="0" anchor="t"/>
-          <a:lstStyle/>
-          <a:p>
-            <a:pPr indent="0" marL="0">
-              <a:buNone/>
-            </a:pPr>
-            <a:r>
-              <a:rPr lang="en-US" sz="1000" dirty="0">
-                <a:solidFill>
-                  <a:schemeClr val="tx1"/>
-                </a:solidFill>
-              </a:rPr>
-              <a:t>Selected country/region screens differ in research depth and company composition and are not representative national market samples. The Nordics screen groups Denmark, Finland, Norway and Sweden. A multinational may appear in multiple country screens; the counts are not additive across countries. A globally marketed product does not establish locally verified use. Percentages show shares within screened comparable companies, not regional adoption, customer penetration or product deployment rates.</a:t>
-            </a:r>
-            <a:endParaRPr lang="en-US" sz="1000" dirty="0"/>
-          </a:p>
-        </p:txBody>
-      </p:sp>
-      <p:sp>
-        <p:nvSpPr>
-          <p:cNvPr id="18" name="slide 5 — evidence boundary"/>
-          <p:cNvSpPr/>
-          <p:nvPr/>
-        </p:nvSpPr>
-        <p:spPr>
-          <a:xfrm>
-            <a:off x="8052816" y="3159252"/>
-            <a:ext cx="3587496" cy="2171700"/>
-          </a:xfrm>
-          <a:prstGeom prst="rect">
-            <a:avLst/>
-          </a:prstGeom>
-          <a:solidFill>
-            <a:schemeClr val="bg1"/>
-          </a:solidFill>
-          <a:ln/>
-          <a:effectLst>
-            <a:outerShdw sx="100000" sy="100000" kx="0" ky="0" algn="bl" rotWithShape="0" blurRad="101600" dist="25400" dir="5400000">
-              <a:srgbClr val="000000">
-                <a:alpha val="10000"/>
-              </a:srgbClr>
-            </a:outerShdw>
-          </a:effectLst>
-        </p:spPr>
-        <p:txBody>
-          <a:bodyPr/>
-          <a:p/>
-        </p:txBody>
-      </p:sp>
-      <p:sp>
-        <p:nvSpPr>
-          <p:cNvPr id="19" name="label"/>
-          <p:cNvSpPr txBox="1"/>
-          <p:nvPr/>
-        </p:nvSpPr>
-        <p:spPr>
-          <a:xfrm>
-            <a:off x="8235696" y="3305556"/>
-            <a:ext cx="3221736" cy="219456"/>
-          </a:xfrm>
-          <a:prstGeom prst="rect">
-            <a:avLst/>
-          </a:prstGeom>
-          <a:noFill/>
-          <a:ln/>
-        </p:spPr>
-        <p:txBody>
-          <a:bodyPr wrap="square" lIns="0" tIns="0" rIns="0" bIns="0" rtlCol="0" anchor="t"/>
-          <a:lstStyle/>
-          <a:p>
-            <a:pPr indent="0" marL="0">
-              <a:buNone/>
-            </a:pPr>
-            <a:r>
-              <a:rPr lang="en-US" sz="1000" b="1" spc="100" kern="0" dirty="0">
-                <a:solidFill>
-                  <a:schemeClr val="accent2"/>
-                </a:solidFill>
-              </a:rPr>
-              <a:t>SLIDE 6 — EVIDENCE BOUNDARY</a:t>
+              <a:t>SLIDE 6 — RWE</a:t>
             </a:r>
             <a:endParaRPr lang="en-US" sz="1000" dirty="0"/>
           </a:p>
@@ -7526,7 +7423,7 @@
         </p:nvSpPr>
         <p:spPr>
           <a:xfrm>
-            <a:off x="8235696" y="3579876"/>
+            <a:off x="4483608" y="3579876"/>
             <a:ext cx="3221736" cy="1677924"/>
           </a:xfrm>
           <a:prstGeom prst="rect">
@@ -7753,7 +7650,7 @@
                   <a:schemeClr val="accent2"/>
                 </a:solidFill>
               </a:rPr>
-              <a:t>SLIDE 7 — EVIDENCE BOUNDARY</a:t>
+              <a:t>SLIDE 7 — SPECIALIZED RWE</a:t>
             </a:r>
             <a:endParaRPr lang="en-US" sz="1000" dirty="0"/>
           </a:p>
@@ -7856,7 +7753,7 @@
                   <a:schemeClr val="accent2"/>
                 </a:solidFill>
               </a:rPr>
-              <a:t>SLIDE 8 — EVIDENCE BOUNDARY</a:t>
+              <a:t>SLIDE 8 — COMMERCIAL INTELLIGENCE</a:t>
             </a:r>
             <a:endParaRPr lang="en-US" sz="1000" dirty="0"/>
           </a:p>
@@ -7959,7 +7856,7 @@
                   <a:schemeClr val="accent2"/>
                 </a:solidFill>
               </a:rPr>
-              <a:t>SLIDE 9 — EVIDENCE BOUNDARY</a:t>
+              <a:t>SLIDE 9 — MEDICAL / REGULATORY</a:t>
             </a:r>
             <a:endParaRPr lang="en-US" sz="1000" dirty="0"/>
           </a:p>
@@ -8062,7 +7959,7 @@
                   <a:schemeClr val="accent2"/>
                 </a:solidFill>
               </a:rPr>
-              <a:t>SLIDE 10 — EVIDENCE BOUNDARY</a:t>
+              <a:t>SLIDE 10 — TRIALS &amp; MARKET ACCESS</a:t>
             </a:r>
             <a:endParaRPr lang="en-US" sz="1000" dirty="0"/>
           </a:p>
@@ -8165,7 +8062,7 @@
                   <a:schemeClr val="accent2"/>
                 </a:solidFill>
               </a:rPr>
-              <a:t>SLIDE 11 — EVIDENCE BOUNDARY</a:t>
+              <a:t>SLIDE 11 — LLM PROVIDERS</a:t>
             </a:r>
             <a:endParaRPr lang="en-US" sz="1000" dirty="0"/>
           </a:p>

</xml_diff>

<commit_message>
Sourced deck: move Slide 7 note onto first notes page, reflow second
Co-Authored-By: Claude Opus 5.5 <noreply@anthropic.com>
Claude-Session: https://claude.ai/code/session_0198bm9pfzRwgZQBqNvd56W8
</commit_message>
<xml_diff>
--- a/deck/Optum-LS-Conversational-AI-sourced.pptx
+++ b/deck/Optum-LS-Conversational-AI-sourced.pptx
@@ -7526,6 +7526,109 @@
           </a:p>
         </p:txBody>
       </p:sp>
+      <p:sp>
+        <p:nvSpPr>
+          <p:cNvPr id="3" name="slide 6 — evidence boundary"/>
+          <p:cNvSpPr/>
+          <p:nvPr/>
+        </p:nvSpPr>
+        <p:spPr>
+          <a:xfrm>
+            <a:off x="8055864" y="3163824"/>
+            <a:ext cx="3587496" cy="2176272"/>
+          </a:xfrm>
+          <a:prstGeom prst="rect">
+            <a:avLst/>
+          </a:prstGeom>
+          <a:solidFill>
+            <a:schemeClr val="bg1"/>
+          </a:solidFill>
+          <a:ln/>
+          <a:effectLst>
+            <a:outerShdw sx="100000" sy="100000" kx="0" ky="0" algn="bl" rotWithShape="0" blurRad="101600" dist="25400" dir="5400000">
+              <a:srgbClr val="000000">
+                <a:alpha val="10000"/>
+              </a:srgbClr>
+            </a:outerShdw>
+          </a:effectLst>
+        </p:spPr>
+        <p:txBody>
+          <a:bodyPr/>
+          <a:p/>
+        </p:txBody>
+      </p:sp>
+      <p:sp>
+        <p:nvSpPr>
+          <p:cNvPr id="4" name="label"/>
+          <p:cNvSpPr txBox="1"/>
+          <p:nvPr/>
+        </p:nvSpPr>
+        <p:spPr>
+          <a:xfrm>
+            <a:off x="8238744" y="3310128"/>
+            <a:ext cx="3221736" cy="219456"/>
+          </a:xfrm>
+          <a:prstGeom prst="rect">
+            <a:avLst/>
+          </a:prstGeom>
+          <a:noFill/>
+          <a:ln/>
+        </p:spPr>
+        <p:txBody>
+          <a:bodyPr wrap="square" lIns="0" tIns="0" rIns="0" bIns="0" rtlCol="0" anchor="t"/>
+          <a:lstStyle/>
+          <a:p>
+            <a:pPr indent="0" marL="0">
+              <a:buNone/>
+            </a:pPr>
+            <a:r>
+              <a:rPr lang="en-US" sz="1000" b="1" spc="100" kern="0" dirty="0">
+                <a:solidFill>
+                  <a:schemeClr val="accent2"/>
+                </a:solidFill>
+              </a:rPr>
+              <a:t>SLIDE 7 — SPECIALIZED RWE</a:t>
+            </a:r>
+            <a:endParaRPr lang="en-US" sz="1000" dirty="0"/>
+          </a:p>
+        </p:txBody>
+      </p:sp>
+      <p:sp>
+        <p:nvSpPr>
+          <p:cNvPr id="5" name="Text 3"/>
+          <p:cNvSpPr txBox="1"/>
+          <p:nvPr/>
+        </p:nvSpPr>
+        <p:spPr>
+          <a:xfrm>
+            <a:off x="8238744" y="3584448"/>
+            <a:ext cx="3221736" cy="1682495"/>
+          </a:xfrm>
+          <a:prstGeom prst="rect">
+            <a:avLst/>
+          </a:prstGeom>
+          <a:noFill/>
+          <a:ln/>
+        </p:spPr>
+        <p:txBody>
+          <a:bodyPr wrap="square" lIns="0" tIns="0" rIns="0" bIns="0" rtlCol="0" anchor="t"/>
+          <a:lstStyle/>
+          <a:p>
+            <a:pPr indent="0" marL="0">
+              <a:buNone/>
+            </a:pPr>
+            <a:r>
+              <a:rPr lang="en-US" sz="1000" dirty="0">
+                <a:solidFill>
+                  <a:schemeClr val="tx1"/>
+                </a:solidFill>
+              </a:rPr>
+              <a:t>Scope: Four qualifying U.S. conversational offerings plus one selected international example. Product descriptions are based on public marketing; study-grade reliability, data entitlements and actual deployment are not independently established.</a:t>
+            </a:r>
+            <a:endParaRPr lang="en-US" sz="1000" dirty="0"/>
+          </a:p>
+        </p:txBody>
+      </p:sp>
     </p:spTree>
   </p:cSld>
   <p:clrMapOvr>
@@ -7591,14 +7694,14 @@
       </p:sp>
       <p:sp>
         <p:nvSpPr>
-          <p:cNvPr id="3" name="slide 6 — evidence boundary"/>
+          <p:cNvPr id="6" name="slide 7 — evidence boundary"/>
           <p:cNvSpPr/>
           <p:nvPr/>
         </p:nvSpPr>
         <p:spPr>
           <a:xfrm>
             <a:off x="548640" y="822960"/>
-            <a:ext cx="3587496" cy="1706880"/>
+            <a:ext cx="3587496" cy="2322576"/>
           </a:xfrm>
           <a:prstGeom prst="rect">
             <a:avLst/>
@@ -7622,7 +7725,7 @@
       </p:sp>
       <p:sp>
         <p:nvSpPr>
-          <p:cNvPr id="4" name="label"/>
+          <p:cNvPr id="7" name="label"/>
           <p:cNvSpPr txBox="1"/>
           <p:nvPr/>
         </p:nvSpPr>
@@ -7650,7 +7753,7 @@
                   <a:schemeClr val="accent2"/>
                 </a:solidFill>
               </a:rPr>
-              <a:t>SLIDE 7 — SPECIALIZED RWE</a:t>
+              <a:t>SLIDE 8 — COMMERCIAL INTELLIGENCE</a:t>
             </a:r>
             <a:endParaRPr lang="en-US" sz="1000" dirty="0"/>
           </a:p>
@@ -7658,14 +7761,14 @@
       </p:sp>
       <p:sp>
         <p:nvSpPr>
-          <p:cNvPr id="5" name="Text 3"/>
+          <p:cNvPr id="8" name="Text 6"/>
           <p:cNvSpPr txBox="1"/>
           <p:nvPr/>
         </p:nvSpPr>
         <p:spPr>
           <a:xfrm>
             <a:off x="731520" y="1243584"/>
-            <a:ext cx="3221736" cy="1213104"/>
+            <a:ext cx="3221736" cy="1828800"/>
           </a:xfrm>
           <a:prstGeom prst="rect">
             <a:avLst/>
@@ -7686,7 +7789,7 @@
                   <a:schemeClr val="tx1"/>
                 </a:solidFill>
               </a:rPr>
-              <a:t>Scope: Four qualifying U.S. conversational offerings plus one selected international example. Product descriptions are based on public marketing; study-grade reliability, data entitlements and actual deployment are not independently established.</a:t>
+              <a:t>Scope: All four qualifying U.S. commercial conversational offerings plus four selected international examples. Customer tasks are not interchangeable; Optum comparisons are based on public offerings, not feature-for-feature validation. International examples are illustrative, not a geographic prevalence comparison.</a:t>
             </a:r>
             <a:endParaRPr lang="en-US" sz="1000" dirty="0"/>
           </a:p>
@@ -7694,14 +7797,14 @@
       </p:sp>
       <p:sp>
         <p:nvSpPr>
-          <p:cNvPr id="6" name="slide 7 — evidence boundary"/>
+          <p:cNvPr id="9" name="slide 8 — evidence boundary"/>
           <p:cNvSpPr/>
           <p:nvPr/>
         </p:nvSpPr>
         <p:spPr>
           <a:xfrm>
-            <a:off x="4300728" y="822960"/>
-            <a:ext cx="3587496" cy="1706880"/>
+            <a:off x="4297680" y="822960"/>
+            <a:ext cx="3587496" cy="2322576"/>
           </a:xfrm>
           <a:prstGeom prst="rect">
             <a:avLst/>
@@ -7725,13 +7828,13 @@
       </p:sp>
       <p:sp>
         <p:nvSpPr>
-          <p:cNvPr id="7" name="label"/>
+          <p:cNvPr id="10" name="label"/>
           <p:cNvSpPr txBox="1"/>
           <p:nvPr/>
         </p:nvSpPr>
         <p:spPr>
           <a:xfrm>
-            <a:off x="4483608" y="969264"/>
+            <a:off x="4480560" y="969264"/>
             <a:ext cx="3221736" cy="219456"/>
           </a:xfrm>
           <a:prstGeom prst="rect">
@@ -7753,7 +7856,7 @@
                   <a:schemeClr val="accent2"/>
                 </a:solidFill>
               </a:rPr>
-              <a:t>SLIDE 8 — COMMERCIAL INTELLIGENCE</a:t>
+              <a:t>SLIDE 9 — MEDICAL / REGULATORY</a:t>
             </a:r>
             <a:endParaRPr lang="en-US" sz="1000" dirty="0"/>
           </a:p>
@@ -7761,14 +7864,14 @@
       </p:sp>
       <p:sp>
         <p:nvSpPr>
-          <p:cNvPr id="8" name="Text 6"/>
+          <p:cNvPr id="11" name="Text 9"/>
           <p:cNvSpPr txBox="1"/>
           <p:nvPr/>
         </p:nvSpPr>
         <p:spPr>
           <a:xfrm>
-            <a:off x="4483608" y="1243584"/>
-            <a:ext cx="3221736" cy="1213104"/>
+            <a:off x="4480560" y="1243584"/>
+            <a:ext cx="3221736" cy="1828800"/>
           </a:xfrm>
           <a:prstGeom prst="rect">
             <a:avLst/>
@@ -7789,7 +7892,7 @@
                   <a:schemeClr val="tx1"/>
                 </a:solidFill>
               </a:rPr>
-              <a:t>Scope: All four qualifying U.S. commercial conversational offerings plus four selected international examples. Customer tasks are not interchangeable; Optum comparisons are based on public offerings, not feature-for-feature validation. International examples are illustrative, not a geographic prevalence comparison.</a:t>
+              <a:t>Three qualifying U.S. offerings plus one selected Spanish example. The examples span distinct tasks; scientific research, medical education, document assistance and pharmacovigilance are not interchangeable. Optum comparisons reflect publicly marketed capabilities, not verified conversational equivalence.</a:t>
             </a:r>
             <a:endParaRPr lang="en-US" sz="1000" dirty="0"/>
           </a:p>
@@ -7797,14 +7900,14 @@
       </p:sp>
       <p:sp>
         <p:nvSpPr>
-          <p:cNvPr id="9" name="slide 8 — evidence boundary"/>
+          <p:cNvPr id="12" name="slide 9 — evidence boundary"/>
           <p:cNvSpPr/>
           <p:nvPr/>
         </p:nvSpPr>
         <p:spPr>
           <a:xfrm>
-            <a:off x="8052816" y="822960"/>
-            <a:ext cx="3587496" cy="1706880"/>
+            <a:off x="8055864" y="822960"/>
+            <a:ext cx="3587496" cy="2322576"/>
           </a:xfrm>
           <a:prstGeom prst="rect">
             <a:avLst/>
@@ -7828,13 +7931,13 @@
       </p:sp>
       <p:sp>
         <p:nvSpPr>
-          <p:cNvPr id="10" name="label"/>
+          <p:cNvPr id="13" name="label"/>
           <p:cNvSpPr txBox="1"/>
           <p:nvPr/>
         </p:nvSpPr>
         <p:spPr>
           <a:xfrm>
-            <a:off x="8235696" y="969264"/>
+            <a:off x="8238744" y="969264"/>
             <a:ext cx="3221736" cy="219456"/>
           </a:xfrm>
           <a:prstGeom prst="rect">
@@ -7856,7 +7959,7 @@
                   <a:schemeClr val="accent2"/>
                 </a:solidFill>
               </a:rPr>
-              <a:t>SLIDE 9 — MEDICAL / REGULATORY</a:t>
+              <a:t>SLIDE 10 — TRIALS &amp; MARKET ACCESS</a:t>
             </a:r>
             <a:endParaRPr lang="en-US" sz="1000" dirty="0"/>
           </a:p>
@@ -7864,14 +7967,14 @@
       </p:sp>
       <p:sp>
         <p:nvSpPr>
-          <p:cNvPr id="11" name="Text 9"/>
+          <p:cNvPr id="14" name="Text 12"/>
           <p:cNvSpPr txBox="1"/>
           <p:nvPr/>
         </p:nvSpPr>
         <p:spPr>
           <a:xfrm>
-            <a:off x="8235696" y="1243584"/>
-            <a:ext cx="3221736" cy="1213104"/>
+            <a:off x="8238744" y="1243584"/>
+            <a:ext cx="3221736" cy="1828800"/>
           </a:xfrm>
           <a:prstGeom prst="rect">
             <a:avLst/>
@@ -7892,7 +7995,7 @@
                   <a:schemeClr val="tx1"/>
                 </a:solidFill>
               </a:rPr>
-              <a:t>Three qualifying U.S. offerings plus one selected Spanish example. The examples span distinct tasks; scientific research, medical education, document assistance and pharmacovigilance are not interchangeable. Optum comparisons reflect publicly marketed capabilities, not verified conversational equivalence.</a:t>
+              <a:t>Clinical trials — one qualifying U.S. offering and one selected Chinese example. Market access — one qualifying U.S. offering. No additional qualifying international market-access offering was identified in the selected inventory. The Optum comparisons are based on customer-task overlap, not identical product functionality.</a:t>
             </a:r>
             <a:endParaRPr lang="en-US" sz="1000" dirty="0"/>
           </a:p>
@@ -7900,14 +8003,14 @@
       </p:sp>
       <p:sp>
         <p:nvSpPr>
-          <p:cNvPr id="12" name="slide 9 — evidence boundary"/>
+          <p:cNvPr id="15" name="slide 10 — evidence boundary"/>
           <p:cNvSpPr/>
           <p:nvPr/>
         </p:nvSpPr>
         <p:spPr>
           <a:xfrm>
-            <a:off x="548640" y="2694432"/>
-            <a:ext cx="3587496" cy="2326640"/>
+            <a:off x="548640" y="3310128"/>
+            <a:ext cx="3587496" cy="2322576"/>
           </a:xfrm>
           <a:prstGeom prst="rect">
             <a:avLst/>
@@ -7931,13 +8034,13 @@
       </p:sp>
       <p:sp>
         <p:nvSpPr>
-          <p:cNvPr id="13" name="label"/>
+          <p:cNvPr id="16" name="label"/>
           <p:cNvSpPr txBox="1"/>
           <p:nvPr/>
         </p:nvSpPr>
         <p:spPr>
           <a:xfrm>
-            <a:off x="731520" y="2840736"/>
+            <a:off x="731520" y="3456432"/>
             <a:ext cx="3221736" cy="219456"/>
           </a:xfrm>
           <a:prstGeom prst="rect">
@@ -7959,7 +8062,7 @@
                   <a:schemeClr val="accent2"/>
                 </a:solidFill>
               </a:rPr>
-              <a:t>SLIDE 10 — TRIALS &amp; MARKET ACCESS</a:t>
+              <a:t>SLIDE 11 — LLM PROVIDERS</a:t>
             </a:r>
             <a:endParaRPr lang="en-US" sz="1000" dirty="0"/>
           </a:p>
@@ -7967,14 +8070,14 @@
       </p:sp>
       <p:sp>
         <p:nvSpPr>
-          <p:cNvPr id="14" name="Text 12"/>
+          <p:cNvPr id="17" name="Text 15"/>
           <p:cNvSpPr txBox="1"/>
           <p:nvPr/>
         </p:nvSpPr>
         <p:spPr>
           <a:xfrm>
-            <a:off x="731520" y="3115056"/>
-            <a:ext cx="3221736" cy="1832864"/>
+            <a:off x="731520" y="3730752"/>
+            <a:ext cx="3221736" cy="1828800"/>
           </a:xfrm>
           <a:prstGeom prst="rect">
             <a:avLst/>
@@ -7995,7 +8098,7 @@
                   <a:schemeClr val="tx1"/>
                 </a:solidFill>
               </a:rPr>
-              <a:t>Clinical trials — one qualifying U.S. offering and one selected Chinese example. Market access — one qualifying U.S. offering. No additional qualifying international market-access offering was identified in the selected inventory. The Optum comparisons are based on customer-task overlap, not identical product functionality.</a:t>
+              <a:t>These are selected publicly documented developments, not an exhaustive assessment of LLM providers. The three approaches are neither mutually exclusive nor predictions of future competition. They do not establish that LLM providers caused the recent RWE launch cluster, are displacing established vendors, or expose an Optum capability gap. Not all LLM provider offerings qualify as conversational products; they are not additions to the deck's product counts. North for Pharma was described as planned; Explore Assistant's general commercial availability was not established in our review.</a:t>
             </a:r>
             <a:endParaRPr lang="en-US" sz="1000" dirty="0"/>
           </a:p>
@@ -8003,14 +8106,89 @@
       </p:sp>
       <p:sp>
         <p:nvSpPr>
-          <p:cNvPr id="15" name="slide 10 — evidence boundary"/>
+          <p:cNvPr id="18" name="Text 2"/>
           <p:cNvSpPr/>
-          <p:nvPr/>
-        </p:nvSpPr>
-        <p:spPr>
-          <a:xfrm>
-            <a:off x="4300728" y="2694432"/>
-            <a:ext cx="3587496" cy="2326640"/>
+          <p:nvPr>
+            <p:ph idx="103" type="title" hasCustomPrompt="1"/>
+          </p:nvPr>
+        </p:nvSpPr>
+        <p:spPr>
+          <a:xfrm>
+            <a:off x="548640" y="640080"/>
+            <a:ext cx="11091672" cy="749808"/>
+          </a:xfrm>
+          <a:prstGeom prst="rect">
+            <a:avLst/>
+          </a:prstGeom>
+          <a:noFill/>
+          <a:ln/>
+        </p:spPr>
+        <p:txBody>
+          <a:bodyPr wrap="square" lIns="0" tIns="0" rIns="0" bIns="0" rtlCol="0" anchor="t"/>
+          <a:lstStyle/>
+          <a:p>
+            <a:pPr algn="l" indent="0" marL="0">
+              <a:buNone/>
+            </a:pPr>
+            <a:endParaRPr lang="en-US" sz="2200" dirty="0"/>
+          </a:p>
+        </p:txBody>
+      </p:sp>
+      <p:sp>
+        <p:nvSpPr>
+          <p:cNvPr id="25" name="Slide Number Placeholder 0"/>
+          <p:cNvSpPr>
+            <a:spLocks noGrp="1"/>
+          </p:cNvSpPr>
+          <p:nvPr>
+            <p:ph type="sldNum" sz="quarter" idx="4294967295"/>
+          </p:nvPr>
+        </p:nvSpPr>
+        <p:spPr>
+          <a:xfrm>
+            <a:off x="10725912" y="6309360"/>
+            <a:ext cx="914400" cy="201168"/>
+          </a:xfrm>
+          <a:prstGeom prst="rect">
+            <a:avLst/>
+          </a:prstGeom>
+          <a:extLst>
+            <a:ext uri="{C572A759-6A51-4108-AA02-DFA0A04FC94B}">
+              <ma14:wrappingTextBoxFlag xmlns:ma14="http://schemas.microsoft.com/office/mac/drawingml/2011/main" val="0"/>
+            </a:ext>
+          </a:extLst>
+        </p:spPr>
+        <p:txBody>
+          <a:bodyPr lIns="0" tIns="0" rIns="0" bIns="0"/>
+          <a:lstStyle>
+            <a:lvl1pPr>
+              <a:defRPr sz="900">
+                <a:solidFill>
+                  <a:schemeClr val="accent4"/>
+                </a:solidFill>
+              </a:defRPr>
+            </a:lvl1pPr>
+          </a:lstStyle>
+          <a:p>
+            <a:pPr algn="r"/>
+            <a:fld id="{F7021451-1387-4CA6-816F-3879F97B5CBC}" type="slidenum">
+              <a:rPr b="0" lang="en-US"/>
+              <a:t>12</a:t>
+            </a:fld>
+            <a:endParaRPr lang="en-US"/>
+          </a:p>
+        </p:txBody>
+      </p:sp>
+      <p:sp>
+        <p:nvSpPr>
+          <p:cNvPr id="26" name="Source convention 13"/>
+          <p:cNvSpPr/>
+          <p:nvPr/>
+        </p:nvSpPr>
+        <p:spPr>
+          <a:xfrm>
+            <a:off x="4297680" y="3310128"/>
+            <a:ext cx="3587496" cy="2322576"/>
           </a:xfrm>
           <a:prstGeom prst="rect">
             <a:avLst/>
@@ -8034,191 +8212,13 @@
       </p:sp>
       <p:sp>
         <p:nvSpPr>
-          <p:cNvPr id="16" name="label"/>
-          <p:cNvSpPr txBox="1"/>
-          <p:nvPr/>
-        </p:nvSpPr>
-        <p:spPr>
-          <a:xfrm>
-            <a:off x="4483608" y="2840736"/>
-            <a:ext cx="3221736" cy="219456"/>
-          </a:xfrm>
-          <a:prstGeom prst="rect">
-            <a:avLst/>
-          </a:prstGeom>
-          <a:noFill/>
-          <a:ln/>
-        </p:spPr>
-        <p:txBody>
-          <a:bodyPr wrap="square" lIns="0" tIns="0" rIns="0" bIns="0" rtlCol="0" anchor="t"/>
-          <a:lstStyle/>
-          <a:p>
-            <a:pPr indent="0" marL="0">
-              <a:buNone/>
-            </a:pPr>
-            <a:r>
-              <a:rPr lang="en-US" sz="1000" b="1" spc="100" kern="0" dirty="0">
-                <a:solidFill>
-                  <a:schemeClr val="accent2"/>
-                </a:solidFill>
-              </a:rPr>
-              <a:t>SLIDE 11 — LLM PROVIDERS</a:t>
-            </a:r>
-            <a:endParaRPr lang="en-US" sz="1000" dirty="0"/>
-          </a:p>
-        </p:txBody>
-      </p:sp>
-      <p:sp>
-        <p:nvSpPr>
-          <p:cNvPr id="17" name="Text 15"/>
-          <p:cNvSpPr txBox="1"/>
-          <p:nvPr/>
-        </p:nvSpPr>
-        <p:spPr>
-          <a:xfrm>
-            <a:off x="4483608" y="3115056"/>
-            <a:ext cx="3221736" cy="1832864"/>
-          </a:xfrm>
-          <a:prstGeom prst="rect">
-            <a:avLst/>
-          </a:prstGeom>
-          <a:noFill/>
-          <a:ln/>
-        </p:spPr>
-        <p:txBody>
-          <a:bodyPr wrap="square" lIns="0" tIns="0" rIns="0" bIns="0" rtlCol="0" anchor="t"/>
-          <a:lstStyle/>
-          <a:p>
-            <a:pPr indent="0" marL="0">
-              <a:buNone/>
-            </a:pPr>
-            <a:r>
-              <a:rPr lang="en-US" sz="1000" dirty="0">
-                <a:solidFill>
-                  <a:schemeClr val="tx1"/>
-                </a:solidFill>
-              </a:rPr>
-              <a:t>These are selected publicly documented developments, not an exhaustive assessment of LLM providers. The three approaches are neither mutually exclusive nor predictions of future competition. They do not establish that LLM providers caused the recent RWE launch cluster, are displacing established vendors, or expose an Optum capability gap. Not all LLM provider offerings qualify as conversational products; they are not additions to the deck's product counts. North for Pharma was described as planned; Explore Assistant's general commercial availability was not established in our review.</a:t>
-            </a:r>
-            <a:endParaRPr lang="en-US" sz="1000" dirty="0"/>
-          </a:p>
-        </p:txBody>
-      </p:sp>
-      <p:sp>
-        <p:nvSpPr>
-          <p:cNvPr id="18" name="Text 2"/>
-          <p:cNvSpPr/>
-          <p:nvPr>
-            <p:ph idx="103" type="title" hasCustomPrompt="1"/>
-          </p:nvPr>
-        </p:nvSpPr>
-        <p:spPr>
-          <a:xfrm>
-            <a:off x="548640" y="640080"/>
-            <a:ext cx="11091672" cy="749808"/>
-          </a:xfrm>
-          <a:prstGeom prst="rect">
-            <a:avLst/>
-          </a:prstGeom>
-          <a:noFill/>
-          <a:ln/>
-        </p:spPr>
-        <p:txBody>
-          <a:bodyPr wrap="square" lIns="0" tIns="0" rIns="0" bIns="0" rtlCol="0" anchor="t"/>
-          <a:lstStyle/>
-          <a:p>
-            <a:pPr algn="l" indent="0" marL="0">
-              <a:buNone/>
-            </a:pPr>
-            <a:endParaRPr lang="en-US" sz="2200" dirty="0"/>
-          </a:p>
-        </p:txBody>
-      </p:sp>
-      <p:sp>
-        <p:nvSpPr>
-          <p:cNvPr id="25" name="Slide Number Placeholder 0"/>
-          <p:cNvSpPr>
-            <a:spLocks noGrp="1"/>
-          </p:cNvSpPr>
-          <p:nvPr>
-            <p:ph type="sldNum" sz="quarter" idx="4294967295"/>
-          </p:nvPr>
-        </p:nvSpPr>
-        <p:spPr>
-          <a:xfrm>
-            <a:off x="10725912" y="6309360"/>
-            <a:ext cx="914400" cy="201168"/>
-          </a:xfrm>
-          <a:prstGeom prst="rect">
-            <a:avLst/>
-          </a:prstGeom>
-          <a:extLst>
-            <a:ext uri="{C572A759-6A51-4108-AA02-DFA0A04FC94B}">
-              <ma14:wrappingTextBoxFlag xmlns:ma14="http://schemas.microsoft.com/office/mac/drawingml/2011/main" val="0"/>
-            </a:ext>
-          </a:extLst>
-        </p:spPr>
-        <p:txBody>
-          <a:bodyPr lIns="0" tIns="0" rIns="0" bIns="0"/>
-          <a:lstStyle>
-            <a:lvl1pPr>
-              <a:defRPr sz="900">
-                <a:solidFill>
-                  <a:schemeClr val="accent4"/>
-                </a:solidFill>
-              </a:defRPr>
-            </a:lvl1pPr>
-          </a:lstStyle>
-          <a:p>
-            <a:pPr algn="r"/>
-            <a:fld id="{F7021451-1387-4CA6-816F-3879F97B5CBC}" type="slidenum">
-              <a:rPr b="0" lang="en-US"/>
-              <a:t>12</a:t>
-            </a:fld>
-            <a:endParaRPr lang="en-US"/>
-          </a:p>
-        </p:txBody>
-      </p:sp>
-      <p:sp>
-        <p:nvSpPr>
-          <p:cNvPr id="26" name="Source convention 13"/>
-          <p:cNvSpPr/>
-          <p:nvPr/>
-        </p:nvSpPr>
-        <p:spPr>
-          <a:xfrm>
-            <a:off x="8058912" y="2694432"/>
-            <a:ext cx="3587496" cy="2326640"/>
-          </a:xfrm>
-          <a:prstGeom prst="rect">
-            <a:avLst/>
-          </a:prstGeom>
-          <a:solidFill>
-            <a:schemeClr val="bg1"/>
-          </a:solidFill>
-          <a:ln/>
-          <a:effectLst>
-            <a:outerShdw sx="100000" sy="100000" kx="0" ky="0" algn="bl" rotWithShape="0" blurRad="101600" dist="25400" dir="5400000">
-              <a:srgbClr val="000000">
-                <a:alpha val="10000"/>
-              </a:srgbClr>
-            </a:outerShdw>
-          </a:effectLst>
-        </p:spPr>
-        <p:txBody>
-          <a:bodyPr/>
-          <a:p/>
-        </p:txBody>
-      </p:sp>
-      <p:sp>
-        <p:nvSpPr>
           <p:cNvPr id="27" name="Source convention 14"/>
           <p:cNvSpPr txBox="1"/>
           <p:nvPr/>
         </p:nvSpPr>
         <p:spPr>
           <a:xfrm>
-            <a:off x="8241792" y="2840736"/>
+            <a:off x="4480560" y="3456432"/>
             <a:ext cx="3221736" cy="219456"/>
           </a:xfrm>
           <a:prstGeom prst="rect">
@@ -8254,8 +8254,8 @@
         </p:nvSpPr>
         <p:spPr>
           <a:xfrm>
-            <a:off x="8241792" y="3115056"/>
-            <a:ext cx="3221736" cy="1832864"/>
+            <a:off x="4480560" y="3730752"/>
+            <a:ext cx="3221736" cy="1828800"/>
           </a:xfrm>
           <a:prstGeom prst="rect">
             <a:avLst/>

</xml_diff>

<commit_message>
Sourced deck: richer Optum LS offerings column on pages 6-10
Bold product names with short capability descriptions, link overlays
re-placed on the rendered product names, page 10 rows and bottom card
resized to fit.

Co-Authored-By: Claude Opus 5.5 <noreply@anthropic.com>
Claude-Session: https://claude.ai/code/session_0198bm9pfzRwgZQBqNvd56W8
</commit_message>
<xml_diff>
--- a/deck/Optum-LS-Conversational-AI-sourced.pptx
+++ b/deck/Optum-LS-Conversational-AI-sourced.pptx
@@ -3714,6 +3714,10 @@
           </a:solidFill>
           <a:ln/>
         </p:spPr>
+        <p:txBody>
+          <a:bodyPr/>
+          <a:p/>
+        </p:txBody>
       </p:sp>
       <p:sp>
         <p:nvSpPr>
@@ -3772,6 +3776,10 @@
           </a:solidFill>
           <a:ln/>
         </p:spPr>
+        <p:txBody>
+          <a:bodyPr/>
+          <a:p/>
+        </p:txBody>
       </p:sp>
       <p:sp>
         <p:nvSpPr>
@@ -3830,6 +3838,10 @@
           </a:solidFill>
           <a:ln/>
         </p:spPr>
+        <p:txBody>
+          <a:bodyPr/>
+          <a:p/>
+        </p:txBody>
       </p:sp>
       <p:sp>
         <p:nvSpPr>
@@ -3888,6 +3900,10 @@
           </a:solidFill>
           <a:ln/>
         </p:spPr>
+        <p:txBody>
+          <a:bodyPr/>
+          <a:p/>
+        </p:txBody>
       </p:sp>
       <p:sp>
         <p:nvSpPr>
@@ -3946,6 +3962,10 @@
           </a:solidFill>
           <a:ln/>
         </p:spPr>
+        <p:txBody>
+          <a:bodyPr/>
+          <a:p/>
+        </p:txBody>
       </p:sp>
       <p:sp>
         <p:nvSpPr>
@@ -4073,7 +4093,7 @@
         </p:nvGraphicFramePr>
         <p:xfrm>
           <a:off x="548640" y="1755648"/>
-          <a:ext cx="11091672" cy="914400"/>
+          <a:ext cx="11091672" cy="1587288"/>
         </p:xfrm>
         <a:graphic>
           <a:graphicData uri="http://schemas.openxmlformats.org/drawingml/2006/table">
@@ -4197,7 +4217,7 @@
                   </a:tcPr>
                 </a:tc>
               </a:tr>
-              <a:tr h="564811">
+              <a:tr h="608076">
                 <a:tc>
                   <a:txBody>
                     <a:bodyPr/>
@@ -4324,12 +4344,44 @@
                         <a:buNone/>
                       </a:pPr>
                       <a:r>
-                        <a:rPr lang="en-US" sz="950" dirty="0">
+                        <a:rPr lang="en-US" sz="950" dirty="0" b="1">
                           <a:solidFill>
                             <a:schemeClr val="tx1"/>
                           </a:solidFill>
                         </a:rPr>
-                        <a:t>Prospector Data Mining Studio; Optum Digital Research Network</a:t>
+                        <a:t>Prospector</a:t>
+                      </a:r>
+                      <a:r>
+                        <a:rPr lang="en-US" sz="950" dirty="0" b="0">
+                          <a:solidFill>
+                            <a:schemeClr val="tx1"/>
+                          </a:solidFill>
+                        </a:rPr>
+                        <a:t> (no-code cohort building, attrition funnels)</a:t>
+                      </a:r>
+                      <a:r>
+                        <a:rPr lang="en-US" sz="950" dirty="0" b="0">
+                          <a:solidFill>
+                            <a:schemeClr val="tx1"/>
+                          </a:solidFill>
+                        </a:rPr>
+                        <a:t>; </a:t>
+                      </a:r>
+                      <a:r>
+                        <a:rPr lang="en-US" sz="950" dirty="0" b="1">
+                          <a:solidFill>
+                            <a:schemeClr val="tx1"/>
+                          </a:solidFill>
+                        </a:rPr>
+                        <a:t>Digital Research Network</a:t>
+                      </a:r>
+                      <a:r>
+                        <a:rPr lang="en-US" sz="950" dirty="0" b="0">
+                          <a:solidFill>
+                            <a:schemeClr val="tx1"/>
+                          </a:solidFill>
+                        </a:rPr>
+                        <a:t> (patient identification, recruitment infrastructure)</a:t>
                       </a:r>
                       <a:endParaRPr lang="en-US" sz="950" dirty="0"/>
                     </a:p>
@@ -4505,12 +4557,36 @@
                         <a:buNone/>
                       </a:pPr>
                       <a:r>
-                        <a:rPr lang="en-US" sz="950" dirty="0">
+                        <a:rPr lang="en-US" sz="950" dirty="0" b="1">
                           <a:solidFill>
                             <a:schemeClr val="tx1"/>
                           </a:solidFill>
                         </a:rPr>
-                        <a:t>Optum True Source supports clinical-trial source-data capture; a directly equivalent document assistant was not established</a:t>
+                        <a:t>True Source</a:t>
+                      </a:r>
+                      <a:r>
+                        <a:rPr lang="en-US" sz="950" dirty="0" b="0">
+                          <a:solidFill>
+                            <a:schemeClr val="tx1"/>
+                          </a:solidFill>
+                        </a:rPr>
+                        <a:t> (electronic source-data capture)</a:t>
+                      </a:r>
+                      <a:r>
+                        <a:rPr lang="en-US" sz="950" dirty="0" b="0">
+                          <a:solidFill>
+                            <a:schemeClr val="tx1"/>
+                          </a:solidFill>
+                        </a:rPr>
+                        <a:t>; </a:t>
+                      </a:r>
+                      <a:r>
+                        <a:rPr lang="en-US" sz="950" dirty="0" b="0">
+                          <a:solidFill>
+                            <a:schemeClr val="tx1"/>
+                          </a:solidFill>
+                        </a:rPr>
+                        <a:t>no comparable conversational document assistant established</a:t>
                       </a:r>
                       <a:endParaRPr lang="en-US" sz="950" dirty="0"/>
                     </a:p>
@@ -4549,7 +4625,7 @@
         </p:nvSpPr>
         <p:spPr>
           <a:xfrm>
-            <a:off x="548640" y="3445976"/>
+            <a:off x="548640" y="3489241"/>
             <a:ext cx="11091672" cy="201168"/>
           </a:xfrm>
           <a:prstGeom prst="rect">
@@ -4592,8 +4668,8 @@
           </p:nvPr>
         </p:nvGraphicFramePr>
         <p:xfrm>
-          <a:off x="548640" y="3720296"/>
-          <a:ext cx="11091672" cy="914400"/>
+          <a:off x="548640" y="3763561"/>
+          <a:ext cx="11091672" cy="1226820"/>
         </p:xfrm>
         <a:graphic>
           <a:graphicData uri="http://schemas.openxmlformats.org/drawingml/2006/table">
@@ -4717,7 +4793,7 @@
                   </a:tcPr>
                 </a:tc>
               </a:tr>
-              <a:tr h="564811">
+              <a:tr h="897636">
                 <a:tc>
                   <a:txBody>
                     <a:bodyPr/>
@@ -4844,12 +4920,68 @@
                         <a:buNone/>
                       </a:pPr>
                       <a:r>
-                        <a:rPr lang="en-US" sz="950" dirty="0">
+                        <a:rPr lang="en-US" sz="950" dirty="0" b="1">
                           <a:solidFill>
                             <a:schemeClr val="tx1"/>
                           </a:solidFill>
                         </a:rPr>
-                        <a:t>Optum HEOR and value evidence; Evidence Engine; health economic and budget impact modeling</a:t>
+                        <a:t>HEOR/value evidence</a:t>
+                      </a:r>
+                      <a:r>
+                        <a:rPr lang="en-US" sz="950" dirty="0" b="0">
+                          <a:solidFill>
+                            <a:schemeClr val="tx1"/>
+                          </a:solidFill>
+                        </a:rPr>
+                        <a:t> (outcomes research, economic analysis)</a:t>
+                      </a:r>
+                      <a:r>
+                        <a:rPr lang="en-US" sz="950" dirty="0" b="0">
+                          <a:solidFill>
+                            <a:schemeClr val="tx1"/>
+                          </a:solidFill>
+                        </a:rPr>
+                        <a:t>; </a:t>
+                      </a:r>
+                      <a:r>
+                        <a:rPr lang="en-US" sz="950" dirty="0" b="1">
+                          <a:solidFill>
+                            <a:schemeClr val="tx1"/>
+                          </a:solidFill>
+                        </a:rPr>
+                        <a:t>Evidence Engine</a:t>
+                      </a:r>
+                      <a:r>
+                        <a:rPr lang="en-US" sz="950" dirty="0" b="0">
+                          <a:solidFill>
+                            <a:schemeClr val="tx1"/>
+                          </a:solidFill>
+                        </a:rPr>
+                        <a:t> (evidence-generation support)</a:t>
+                      </a:r>
+                      <a:r>
+                        <a:rPr lang="en-US" sz="950" dirty="0" b="0">
+                          <a:solidFill>
+                            <a:schemeClr val="tx1"/>
+                          </a:solidFill>
+                        </a:rPr>
+                        <a:t>; </a:t>
+                      </a:r>
+                      <a:r>
+                        <a:rPr lang="en-US" sz="950" dirty="0" b="1">
+                          <a:solidFill>
+                            <a:schemeClr val="tx1"/>
+                          </a:solidFill>
+                        </a:rPr>
+                        <a:t>health economic and budget impact modeling</a:t>
+                      </a:r>
+                      <a:r>
+                        <a:rPr lang="en-US" sz="950" dirty="0" b="0">
+                          <a:solidFill>
+                            <a:schemeClr val="tx1"/>
+                          </a:solidFill>
+                        </a:rPr>
+                        <a:t> (cost and budget scenarios)</a:t>
                       </a:r>
                       <a:endParaRPr lang="en-US" sz="950" dirty="0"/>
                     </a:p>
@@ -4888,8 +5020,8 @@
         </p:nvSpPr>
         <p:spPr>
           <a:xfrm>
-            <a:off x="548640" y="4797171"/>
-            <a:ext cx="11091672" cy="1256157"/>
+            <a:off x="548640" y="5136685"/>
+            <a:ext cx="11091672" cy="971507"/>
           </a:xfrm>
           <a:prstGeom prst="rect">
             <a:avLst/>
@@ -4906,6 +5038,10 @@
             </a:outerShdw>
           </a:effectLst>
         </p:spPr>
+        <p:txBody>
+          <a:bodyPr/>
+          <a:p/>
+        </p:txBody>
       </p:sp>
       <p:sp>
         <p:nvSpPr>
@@ -4915,7 +5051,7 @@
         </p:nvSpPr>
         <p:spPr>
           <a:xfrm>
-            <a:off x="749808" y="4980051"/>
+            <a:off x="749808" y="5183526"/>
             <a:ext cx="10689336" cy="256032"/>
           </a:xfrm>
           <a:prstGeom prst="rect">
@@ -4951,8 +5087,8 @@
         </p:nvSpPr>
         <p:spPr>
           <a:xfrm>
-            <a:off x="749808" y="5309235"/>
-            <a:ext cx="10689336" cy="616077"/>
+            <a:off x="749808" y="5494422"/>
+            <a:ext cx="10689336" cy="566928"/>
           </a:xfrm>
           <a:prstGeom prst="rect">
             <a:avLst/>
@@ -4968,7 +5104,7 @@
               <a:buNone/>
             </a:pPr>
             <a:r>
-              <a:rPr lang="en-US" sz="1050" b="1" dirty="0">
+              <a:rPr lang="en-US" sz="1000" b="1" dirty="0">
                 <a:solidFill>
                   <a:schemeClr val="tx1"/>
                 </a:solidFill>
@@ -4985,7 +5121,7 @@
               <a:buNone/>
             </a:pPr>
             <a:r>
-              <a:rPr lang="en-US" sz="1050" b="1" dirty="0">
+              <a:rPr lang="en-US" sz="1000" b="1" dirty="0">
                 <a:solidFill>
                   <a:schemeClr val="tx1"/>
                 </a:solidFill>
@@ -5008,7 +5144,7 @@
         </p:nvSpPr>
         <p:spPr>
           <a:xfrm>
-            <a:off x="10725912" y="6309360"/>
+            <a:off x="10725912" y="6685450"/>
             <a:ext cx="914400" cy="201168"/>
           </a:xfrm>
           <a:prstGeom prst="rect">
@@ -5051,7 +5187,7 @@
         </p:nvSpPr>
         <p:spPr>
           <a:xfrm>
-            <a:off x="3465236" y="2253602"/>
+            <a:off x="3465236" y="2275234"/>
             <a:ext cx="1119405" cy="89280"/>
           </a:xfrm>
           <a:prstGeom prst="rect">
@@ -5086,16 +5222,16 @@
       </p:sp>
       <p:sp>
         <p:nvSpPr>
-          <p:cNvPr id="27" name="Invisible source link 9: https://business.optum.com/en/data-analytics/life-">
-            <a:hlinkClick r:id="rId4"/>
+          <p:cNvPr id="30" name="Invisible source link 9: https://cn.taimei.com/index/product/id/41">
+            <a:hlinkClick r:id="rId5"/>
           </p:cNvPr>
           <p:cNvSpPr/>
           <p:nvPr/>
         </p:nvSpPr>
         <p:spPr>
           <a:xfrm>
-            <a:off x="8714349" y="2321280"/>
-            <a:ext cx="1620161" cy="113398"/>
+            <a:off x="3408354" y="2903825"/>
+            <a:ext cx="517138" cy="89280"/>
           </a:xfrm>
           <a:prstGeom prst="rect">
             <a:avLst/>
@@ -5129,16 +5265,16 @@
       </p:sp>
       <p:sp>
         <p:nvSpPr>
-          <p:cNvPr id="28" name="Invisible source link 9: https://business.optum.com/en/data-analytics/life-">
-            <a:hlinkClick r:id="rId4"/>
+          <p:cNvPr id="32" name="Invisible source link 9: https://www.navlin.com/products/tender">
+            <a:hlinkClick r:id="rId6"/>
           </p:cNvPr>
           <p:cNvSpPr/>
           <p:nvPr/>
         </p:nvSpPr>
         <p:spPr>
           <a:xfrm>
-            <a:off x="10409922" y="2321280"/>
-            <a:ext cx="1107162" cy="113398"/>
+            <a:off x="3719031" y="4427791"/>
+            <a:ext cx="684167" cy="89280"/>
           </a:xfrm>
           <a:prstGeom prst="rect">
             <a:avLst/>
@@ -5172,7 +5308,7 @@
       </p:sp>
       <p:sp>
         <p:nvSpPr>
-          <p:cNvPr id="29" name="Invisible source link 9: https://business.optum.com/en/data-analytics/life-">
+          <p:cNvPr id="9520" name="Invisible source link 10: https://business.optum.com/en/data-analytics/life-sciences/clinical-trial-design.html">
             <a:hlinkClick r:id="rId4"/>
           </p:cNvPr>
           <p:cNvSpPr/>
@@ -5180,8 +5316,8 @@
         </p:nvSpPr>
         <p:spPr>
           <a:xfrm>
-            <a:off x="8712545" y="2431084"/>
-            <a:ext cx="636288" cy="89280"/>
+            <a:off x="8704795" y="2185862"/>
+            <a:ext cx="634592" cy="134588"/>
           </a:xfrm>
           <a:prstGeom prst="rect">
             <a:avLst/>
@@ -5215,16 +5351,16 @@
       </p:sp>
       <p:sp>
         <p:nvSpPr>
-          <p:cNvPr id="30" name="Invisible source link 9: https://cn.taimei.com/index/product/id/41">
-            <a:hlinkClick r:id="rId5"/>
+          <p:cNvPr id="9521" name="Invisible source link 10: https://business.optum.com/en/data-analytics/life-sciences/clinical-trial-design.html">
+            <a:hlinkClick r:id="rId4"/>
           </p:cNvPr>
           <p:cNvSpPr/>
           <p:nvPr/>
         </p:nvSpPr>
         <p:spPr>
           <a:xfrm>
-            <a:off x="3408354" y="2860560"/>
-            <a:ext cx="517138" cy="89280"/>
+            <a:off x="9198724" y="2321574"/>
+            <a:ext cx="1449602" cy="134588"/>
           </a:xfrm>
           <a:prstGeom prst="rect">
             <a:avLst/>
@@ -5258,7 +5394,7 @@
       </p:sp>
       <p:sp>
         <p:nvSpPr>
-          <p:cNvPr id="31" name="Invisible source link 9: https://business.optum.com/en/data-analytics/life-">
+          <p:cNvPr id="9522" name="Invisible source link 10: https://business.optum.com/en/data-analytics/life-sciences/clinical-trial-design.html">
             <a:hlinkClick r:id="rId4"/>
           </p:cNvPr>
           <p:cNvSpPr/>
@@ -5266,8 +5402,8 @@
         </p:nvSpPr>
         <p:spPr>
           <a:xfrm>
-            <a:off x="8710031" y="2796120"/>
-            <a:ext cx="1042012" cy="109804"/>
+            <a:off x="8704795" y="2814778"/>
+            <a:ext cx="694168" cy="134588"/>
           </a:xfrm>
           <a:prstGeom prst="rect">
             <a:avLst/>
@@ -5301,16 +5437,16 @@
       </p:sp>
       <p:sp>
         <p:nvSpPr>
-          <p:cNvPr id="32" name="Invisible source link 9: https://www.navlin.com/products/tender">
-            <a:hlinkClick r:id="rId6"/>
+          <p:cNvPr id="9523" name="Invisible source link 10: https://business.optum.com/en/data-analytics/life-sciences/heor.html">
+            <a:hlinkClick r:id="rId7"/>
           </p:cNvPr>
           <p:cNvSpPr/>
           <p:nvPr/>
         </p:nvSpPr>
         <p:spPr>
           <a:xfrm>
-            <a:off x="3719031" y="4218114"/>
-            <a:ext cx="684167" cy="89280"/>
+            <a:off x="8704795" y="4270262"/>
+            <a:ext cx="1236262" cy="134588"/>
           </a:xfrm>
           <a:prstGeom prst="rect">
             <a:avLst/>
@@ -5344,16 +5480,16 @@
       </p:sp>
       <p:sp>
         <p:nvSpPr>
-          <p:cNvPr id="33" name="Invisible source link 9: https://business.optum.com/en/data-analytics/life-">
-            <a:hlinkClick r:id="rId7"/>
+          <p:cNvPr id="9524" name="Invisible source link 10: https://business.optum.com/en/data-analytics/life-sciences/evidence-engine.html">
+            <a:hlinkClick r:id="rId8"/>
           </p:cNvPr>
           <p:cNvSpPr/>
           <p:nvPr/>
         </p:nvSpPr>
         <p:spPr>
           <a:xfrm>
-            <a:off x="9109264" y="4221353"/>
-            <a:ext cx="333892" cy="86042"/>
+            <a:off x="9794519" y="4405974"/>
+            <a:ext cx="962019" cy="134588"/>
           </a:xfrm>
           <a:prstGeom prst="rect">
             <a:avLst/>
@@ -5387,16 +5523,16 @@
       </p:sp>
       <p:sp>
         <p:nvSpPr>
-          <p:cNvPr id="34" name="Invisible source link 9: https://business.optum.com/en/data-analytics/life-">
-            <a:hlinkClick r:id="rId8"/>
+          <p:cNvPr id="9525" name="Invisible source link 10: https://business.optum.com/en/data-analytics/life-sciences/value-based-contracts.html">
+            <a:hlinkClick r:id="rId9"/>
           </p:cNvPr>
           <p:cNvSpPr/>
           <p:nvPr/>
         </p:nvSpPr>
         <p:spPr>
           <a:xfrm>
-            <a:off x="10594972" y="4218114"/>
-            <a:ext cx="889727" cy="113042"/>
+            <a:off x="9815753" y="4541699"/>
+            <a:ext cx="1630018" cy="134588"/>
           </a:xfrm>
           <a:prstGeom prst="rect">
             <a:avLst/>
@@ -5430,7 +5566,7 @@
       </p:sp>
       <p:sp>
         <p:nvSpPr>
-          <p:cNvPr id="35" name="Invisible source link 9: https://business.optum.com/en/data-analytics/life-">
+          <p:cNvPr id="9526" name="Invisible source link 10: https://business.optum.com/en/data-analytics/life-sciences/value-based-contracts.html">
             <a:hlinkClick r:id="rId9"/>
           </p:cNvPr>
           <p:cNvSpPr/>
@@ -5438,8 +5574,8 @@
         </p:nvSpPr>
         <p:spPr>
           <a:xfrm>
-            <a:off x="8712901" y="4353839"/>
-            <a:ext cx="2408556" cy="113042"/>
+            <a:off x="8704795" y="4677411"/>
+            <a:ext cx="955145" cy="134588"/>
           </a:xfrm>
           <a:prstGeom prst="rect">
             <a:avLst/>
@@ -17505,12 +17641,44 @@
                         <a:buNone/>
                       </a:pPr>
                       <a:r>
-                        <a:rPr lang="en-US" sz="950" dirty="0">
+                        <a:rPr lang="en-US" sz="950" dirty="0" b="1">
                           <a:solidFill>
                             <a:schemeClr val="tx1"/>
                           </a:solidFill>
                         </a:rPr>
-                        <a:t>Market Clarity Data; linked claims/EHR data; Enriched Clinical Data</a:t>
+                        <a:t>Market Clarity Data</a:t>
+                      </a:r>
+                      <a:r>
+                        <a:rPr lang="en-US" sz="950" dirty="0" b="0">
+                          <a:solidFill>
+                            <a:schemeClr val="tx1"/>
+                          </a:solidFill>
+                        </a:rPr>
+                        <a:t> (linked claims/EHR)</a:t>
+                      </a:r>
+                      <a:r>
+                        <a:rPr lang="en-US" sz="950" dirty="0" b="0">
+                          <a:solidFill>
+                            <a:schemeClr val="tx1"/>
+                          </a:solidFill>
+                        </a:rPr>
+                        <a:t>; </a:t>
+                      </a:r>
+                      <a:r>
+                        <a:rPr lang="en-US" sz="950" dirty="0" b="1">
+                          <a:solidFill>
+                            <a:schemeClr val="tx1"/>
+                          </a:solidFill>
+                        </a:rPr>
+                        <a:t>Enriched Clinical Data</a:t>
+                      </a:r>
+                      <a:r>
+                        <a:rPr lang="en-US" sz="950" dirty="0" b="0">
+                          <a:solidFill>
+                            <a:schemeClr val="tx1"/>
+                          </a:solidFill>
+                        </a:rPr>
+                        <a:t> (NLP-extracted clinical variables)</a:t>
                       </a:r>
                       <a:endParaRPr lang="en-US" sz="950" dirty="0"/>
                     </a:p>
@@ -17798,12 +17966,68 @@
                         <a:buNone/>
                       </a:pPr>
                       <a:r>
-                        <a:rPr lang="en-US" sz="950" dirty="0">
+                        <a:rPr lang="en-US" sz="950" dirty="0" b="1">
                           <a:solidFill>
                             <a:schemeClr val="tx1"/>
                           </a:solidFill>
                         </a:rPr>
-                        <a:t>Analytics on Demand; Clinical Notes Lab; Prospector</a:t>
+                        <a:t>Analytics on Demand</a:t>
+                      </a:r>
+                      <a:r>
+                        <a:rPr lang="en-US" sz="950" dirty="0" b="0">
+                          <a:solidFill>
+                            <a:schemeClr val="tx1"/>
+                          </a:solidFill>
+                        </a:rPr>
+                        <a:t> (advanced statistical models)</a:t>
+                      </a:r>
+                      <a:r>
+                        <a:rPr lang="en-US" sz="950" dirty="0" b="0">
+                          <a:solidFill>
+                            <a:schemeClr val="tx1"/>
+                          </a:solidFill>
+                        </a:rPr>
+                        <a:t>; </a:t>
+                      </a:r>
+                      <a:r>
+                        <a:rPr lang="en-US" sz="950" dirty="0" b="1">
+                          <a:solidFill>
+                            <a:schemeClr val="tx1"/>
+                          </a:solidFill>
+                        </a:rPr>
+                        <a:t>Clinical Notes Lab</a:t>
+                      </a:r>
+                      <a:r>
+                        <a:rPr lang="en-US" sz="950" dirty="0" b="0">
+                          <a:solidFill>
+                            <a:schemeClr val="tx1"/>
+                          </a:solidFill>
+                        </a:rPr>
+                        <a:t> (NLP/LLMs, custom AI models)</a:t>
+                      </a:r>
+                      <a:r>
+                        <a:rPr lang="en-US" sz="950" dirty="0" b="0">
+                          <a:solidFill>
+                            <a:schemeClr val="tx1"/>
+                          </a:solidFill>
+                        </a:rPr>
+                        <a:t>; </a:t>
+                      </a:r>
+                      <a:r>
+                        <a:rPr lang="en-US" sz="950" dirty="0" b="1">
+                          <a:solidFill>
+                            <a:schemeClr val="tx1"/>
+                          </a:solidFill>
+                        </a:rPr>
+                        <a:t>Prospector</a:t>
+                      </a:r>
+                      <a:r>
+                        <a:rPr lang="en-US" sz="950" dirty="0" b="0">
+                          <a:solidFill>
+                            <a:schemeClr val="tx1"/>
+                          </a:solidFill>
+                        </a:rPr>
+                        <a:t> (no-code cohort building, attrition analysis)</a:t>
                       </a:r>
                       <a:endParaRPr lang="en-US" sz="950" dirty="0"/>
                     </a:p>
@@ -18030,12 +18254,44 @@
                         <a:buNone/>
                       </a:pPr>
                       <a:r>
-                        <a:rPr lang="en-US" sz="950" dirty="0">
+                        <a:rPr lang="en-US" sz="950" dirty="0" b="1">
                           <a:solidFill>
                             <a:schemeClr val="tx1"/>
                           </a:solidFill>
                         </a:rPr>
-                        <a:t>Analytics on Demand; epidemiology research services</a:t>
+                        <a:t>Analytics on Demand</a:t>
+                      </a:r>
+                      <a:r>
+                        <a:rPr lang="en-US" sz="950" dirty="0" b="0">
+                          <a:solidFill>
+                            <a:schemeClr val="tx1"/>
+                          </a:solidFill>
+                        </a:rPr>
+                        <a:t> (statistical modeling, decision trees)</a:t>
+                      </a:r>
+                      <a:r>
+                        <a:rPr lang="en-US" sz="950" dirty="0" b="0">
+                          <a:solidFill>
+                            <a:schemeClr val="tx1"/>
+                          </a:solidFill>
+                        </a:rPr>
+                        <a:t>; </a:t>
+                      </a:r>
+                      <a:r>
+                        <a:rPr lang="en-US" sz="950" dirty="0" b="1">
+                          <a:solidFill>
+                            <a:schemeClr val="tx1"/>
+                          </a:solidFill>
+                        </a:rPr>
+                        <a:t>epidemiology research services</a:t>
+                      </a:r>
+                      <a:r>
+                        <a:rPr lang="en-US" sz="950" dirty="0" b="0">
+                          <a:solidFill>
+                            <a:schemeClr val="tx1"/>
+                          </a:solidFill>
+                        </a:rPr>
+                        <a:t> (advanced study methods, scientific review)</a:t>
                       </a:r>
                       <a:endParaRPr lang="en-US" sz="950" dirty="0"/>
                     </a:p>
@@ -18341,16 +18597,16 @@
       </p:sp>
       <p:sp>
         <p:nvSpPr>
-          <p:cNvPr id="29" name="Invisible source link 5: https://business.optum.com/en/data-analytics/life-">
-            <a:hlinkClick r:id="rId5"/>
+          <p:cNvPr id="33" name="Invisible source link 5: https://www.komodohealth.com/product/marmot/">
+            <a:hlinkClick r:id="rId8"/>
           </p:cNvPr>
           <p:cNvSpPr/>
           <p:nvPr/>
         </p:nvSpPr>
         <p:spPr>
           <a:xfrm>
-            <a:off x="8714349" y="2215438"/>
-            <a:ext cx="1022923" cy="113398"/>
+            <a:off x="3900118" y="3032277"/>
+            <a:ext cx="426779" cy="84963"/>
           </a:xfrm>
           <a:prstGeom prst="rect">
             <a:avLst/>
@@ -18384,16 +18640,16 @@
       </p:sp>
       <p:sp>
         <p:nvSpPr>
-          <p:cNvPr id="30" name="Invisible source link 5: https://business.optum.com/en/data-analytics/life-">
-            <a:hlinkClick r:id="rId6"/>
+          <p:cNvPr id="34" name="Invisible source link 5: https://www.komodohealth.com/press/komodo-health-u">
+            <a:hlinkClick r:id="rId9"/>
           </p:cNvPr>
           <p:cNvSpPr/>
           <p:nvPr/>
         </p:nvSpPr>
         <p:spPr>
           <a:xfrm>
-            <a:off x="9809815" y="2215438"/>
-            <a:ext cx="1238568" cy="89280"/>
+            <a:off x="4602828" y="3032277"/>
+            <a:ext cx="346490" cy="108724"/>
           </a:xfrm>
           <a:prstGeom prst="rect">
             <a:avLst/>
@@ -18427,16 +18683,16 @@
       </p:sp>
       <p:sp>
         <p:nvSpPr>
-          <p:cNvPr id="31" name="Invisible source link 5: https://business.optum.com/en/data-analytics/life-">
-            <a:hlinkClick r:id="rId7"/>
+          <p:cNvPr id="35" name="Invisible source link 5: https://www.truveta.com/blog/announcement/truveta-">
+            <a:hlinkClick r:id="rId10"/>
           </p:cNvPr>
           <p:cNvSpPr/>
           <p:nvPr/>
         </p:nvSpPr>
         <p:spPr>
           <a:xfrm>
-            <a:off x="11123083" y="2215438"/>
-            <a:ext cx="394369" cy="89280"/>
+            <a:off x="3467040" y="3214446"/>
+            <a:ext cx="1121208" cy="113398"/>
           </a:xfrm>
           <a:prstGeom prst="rect">
             <a:avLst/>
@@ -18470,16 +18726,16 @@
       </p:sp>
       <p:sp>
         <p:nvSpPr>
-          <p:cNvPr id="32" name="Invisible source link 5: https://business.optum.com/en/data-analytics/life-">
-            <a:hlinkClick r:id="rId7"/>
+          <p:cNvPr id="36" name="Invisible source link 5: https://briya.com/aire-population-agent/">
+            <a:hlinkClick r:id="rId11"/>
           </p:cNvPr>
           <p:cNvSpPr/>
           <p:nvPr/>
         </p:nvSpPr>
         <p:spPr>
           <a:xfrm>
-            <a:off x="8709663" y="2325242"/>
-            <a:ext cx="772368" cy="89280"/>
+            <a:off x="3339241" y="3400920"/>
+            <a:ext cx="1312367" cy="113398"/>
           </a:xfrm>
           <a:prstGeom prst="rect">
             <a:avLst/>
@@ -18513,16 +18769,16 @@
       </p:sp>
       <p:sp>
         <p:nvSpPr>
-          <p:cNvPr id="33" name="Invisible source link 5: https://www.komodohealth.com/product/marmot/">
-            <a:hlinkClick r:id="rId8"/>
+          <p:cNvPr id="40" name="Invisible source link 5: https://panalgo.com/ella/">
+            <a:hlinkClick r:id="rId15"/>
           </p:cNvPr>
           <p:cNvSpPr/>
           <p:nvPr/>
         </p:nvSpPr>
         <p:spPr>
           <a:xfrm>
-            <a:off x="3900118" y="3032277"/>
-            <a:ext cx="426779" cy="84963"/>
+            <a:off x="3545157" y="4122001"/>
+            <a:ext cx="348649" cy="89280"/>
           </a:xfrm>
           <a:prstGeom prst="rect">
             <a:avLst/>
@@ -18556,16 +18812,16 @@
       </p:sp>
       <p:sp>
         <p:nvSpPr>
-          <p:cNvPr id="34" name="Invisible source link 5: https://www.komodohealth.com/press/komodo-health-u">
-            <a:hlinkClick r:id="rId9"/>
+          <p:cNvPr id="41" name="Invisible source link 5: https://www.bcplatforms.com/bc-catalyst">
+            <a:hlinkClick r:id="rId16"/>
           </p:cNvPr>
           <p:cNvSpPr/>
           <p:nvPr/>
         </p:nvSpPr>
         <p:spPr>
           <a:xfrm>
-            <a:off x="4602828" y="3032277"/>
-            <a:ext cx="346490" cy="108724"/>
+            <a:off x="3716872" y="4308487"/>
+            <a:ext cx="667975" cy="113398"/>
           </a:xfrm>
           <a:prstGeom prst="rect">
             <a:avLst/>
@@ -18599,16 +18855,16 @@
       </p:sp>
       <p:sp>
         <p:nvSpPr>
-          <p:cNvPr id="35" name="Invisible source link 5: https://www.truveta.com/blog/announcement/truveta-">
-            <a:hlinkClick r:id="rId10"/>
+          <p:cNvPr id="9500" name="Invisible source link 6: https://business.optum.com/en/data-analytics/life-sciences/real-world-data/market-clarity-data.html">
+            <a:hlinkClick r:id="rId5"/>
           </p:cNvPr>
           <p:cNvSpPr/>
           <p:nvPr/>
         </p:nvSpPr>
         <p:spPr>
           <a:xfrm>
-            <a:off x="3467040" y="3214446"/>
-            <a:ext cx="1121208" cy="113398"/>
+            <a:off x="8704795" y="2126095"/>
+            <a:ext cx="1088769" cy="134588"/>
           </a:xfrm>
           <a:prstGeom prst="rect">
             <a:avLst/>
@@ -18642,16 +18898,16 @@
       </p:sp>
       <p:sp>
         <p:nvSpPr>
-          <p:cNvPr id="36" name="Invisible source link 5: https://briya.com/aire-population-agent/">
-            <a:hlinkClick r:id="rId11"/>
+          <p:cNvPr id="9501" name="Invisible source link 6: https://business.optum.com/en/data-analytics/life-sciences/real-world-data/enriched-clinical-data.html">
+            <a:hlinkClick r:id="rId7"/>
           </p:cNvPr>
           <p:cNvSpPr/>
           <p:nvPr/>
         </p:nvSpPr>
         <p:spPr>
           <a:xfrm>
-            <a:off x="3339241" y="3400920"/>
-            <a:ext cx="1312367" cy="113398"/>
+            <a:off x="10951197" y="2126095"/>
+            <a:ext cx="513511" cy="134588"/>
           </a:xfrm>
           <a:prstGeom prst="rect">
             <a:avLst/>
@@ -18685,16 +18941,16 @@
       </p:sp>
       <p:sp>
         <p:nvSpPr>
-          <p:cNvPr id="37" name="Invisible source link 5: https://business.optum.com/en/data-analytics/life-">
-            <a:hlinkClick r:id="rId12"/>
+          <p:cNvPr id="9502" name="Invisible source link 6: https://business.optum.com/en/data-analytics/life-sciences/real-world-data/enriched-clinical-data.html">
+            <a:hlinkClick r:id="rId7"/>
           </p:cNvPr>
           <p:cNvSpPr/>
           <p:nvPr/>
         </p:nvSpPr>
         <p:spPr>
           <a:xfrm>
-            <a:off x="8704620" y="3214433"/>
-            <a:ext cx="1131648" cy="113042"/>
+            <a:off x="8704795" y="2261820"/>
+            <a:ext cx="721665" cy="134588"/>
           </a:xfrm>
           <a:prstGeom prst="rect">
             <a:avLst/>
@@ -18728,16 +18984,16 @@
       </p:sp>
       <p:sp>
         <p:nvSpPr>
-          <p:cNvPr id="38" name="Invisible source link 5: https://business.optum.com/en/data-analytics/life-">
-            <a:hlinkClick r:id="rId13"/>
+          <p:cNvPr id="9503" name="Invisible source link 6: https://business.optum.com/en/data-analytics/life-sciences/heor/exploratory-analysis.html">
+            <a:hlinkClick r:id="rId12"/>
           </p:cNvPr>
           <p:cNvSpPr/>
           <p:nvPr/>
         </p:nvSpPr>
         <p:spPr>
           <a:xfrm>
-            <a:off x="9915287" y="3214433"/>
-            <a:ext cx="960643" cy="89280"/>
+            <a:off x="8704795" y="2989022"/>
+            <a:ext cx="1222996" cy="134588"/>
           </a:xfrm>
           <a:prstGeom prst="rect">
             <a:avLst/>
@@ -18771,16 +19027,16 @@
       </p:sp>
       <p:sp>
         <p:nvSpPr>
-          <p:cNvPr id="39" name="Invisible source link 5: https://business.optum.com/en/data-analytics/life-">
-            <a:hlinkClick r:id="rId14"/>
+          <p:cNvPr id="9504" name="Invisible source link 6: https://business.optum.com/en/data-analytics/life-sciences/real-world-data/clinical-notes.html">
+            <a:hlinkClick r:id="rId13"/>
           </p:cNvPr>
           <p:cNvSpPr/>
           <p:nvPr/>
         </p:nvSpPr>
         <p:spPr>
           <a:xfrm>
-            <a:off x="10956042" y="3218751"/>
-            <a:ext cx="571849" cy="108724"/>
+            <a:off x="9198724" y="3124734"/>
+            <a:ext cx="1041856" cy="134588"/>
           </a:xfrm>
           <a:prstGeom prst="rect">
             <a:avLst/>
@@ -18814,16 +19070,16 @@
       </p:sp>
       <p:sp>
         <p:nvSpPr>
-          <p:cNvPr id="40" name="Invisible source link 5: https://panalgo.com/ella/">
-            <a:hlinkClick r:id="rId15"/>
+          <p:cNvPr id="9505" name="Invisible source link 6: https://business.optum.com/en/data-analytics/life-sciences/clinical-trial-design.html">
+            <a:hlinkClick r:id="rId14"/>
           </p:cNvPr>
           <p:cNvSpPr/>
           <p:nvPr/>
         </p:nvSpPr>
         <p:spPr>
           <a:xfrm>
-            <a:off x="3545157" y="4122001"/>
-            <a:ext cx="348649" cy="89280"/>
+            <a:off x="9198724" y="3260459"/>
+            <a:ext cx="634592" cy="134588"/>
           </a:xfrm>
           <a:prstGeom prst="rect">
             <a:avLst/>
@@ -18857,16 +19113,16 @@
       </p:sp>
       <p:sp>
         <p:nvSpPr>
-          <p:cNvPr id="41" name="Invisible source link 5: https://www.bcplatforms.com/bc-catalyst">
-            <a:hlinkClick r:id="rId16"/>
+          <p:cNvPr id="9506" name="Invisible source link 6: https://business.optum.com/en/data-analytics/life-sciences/heor/exploratory-analysis.html">
+            <a:hlinkClick r:id="rId12"/>
           </p:cNvPr>
           <p:cNvSpPr/>
           <p:nvPr/>
         </p:nvSpPr>
         <p:spPr>
           <a:xfrm>
-            <a:off x="3716872" y="4308487"/>
-            <a:ext cx="667975" cy="113398"/>
+            <a:off x="8704795" y="4125901"/>
+            <a:ext cx="1222996" cy="134588"/>
           </a:xfrm>
           <a:prstGeom prst="rect">
             <a:avLst/>
@@ -18900,50 +19156,7 @@
       </p:sp>
       <p:sp>
         <p:nvSpPr>
-          <p:cNvPr id="42" name="Invisible source link 5: https://business.optum.com/en/data-analytics/life-">
-            <a:hlinkClick r:id="rId12"/>
-          </p:cNvPr>
-          <p:cNvSpPr/>
-          <p:nvPr/>
-        </p:nvSpPr>
-        <p:spPr>
-          <a:xfrm>
-            <a:off x="8704620" y="4215244"/>
-            <a:ext cx="1131648" cy="113398"/>
-          </a:xfrm>
-          <a:prstGeom prst="rect">
-            <a:avLst/>
-          </a:prstGeom>
-          <a:noFill/>
-          <a:ln>
-            <a:noFill/>
-          </a:ln>
-        </p:spPr>
-        <p:style>
-          <a:lnRef idx="1">
-            <a:schemeClr val="accent1"/>
-          </a:lnRef>
-          <a:fillRef idx="3">
-            <a:schemeClr val="accent1"/>
-          </a:fillRef>
-          <a:effectRef idx="2">
-            <a:schemeClr val="accent1"/>
-          </a:effectRef>
-          <a:fontRef idx="minor">
-            <a:schemeClr val="lt1"/>
-          </a:fontRef>
-        </p:style>
-        <p:txBody>
-          <a:bodyPr rtlCol="0" anchor="ctr"/>
-          <a:lstStyle/>
-          <a:p>
-            <a:pPr algn="ctr"/>
-          </a:p>
-        </p:txBody>
-      </p:sp>
-      <p:sp>
-        <p:nvSpPr>
-          <p:cNvPr id="43" name="Invisible source link 5: https://business.optum.com/en/data-analytics/life-">
+          <p:cNvPr id="9507" name="Invisible source link 6: https://business.optum.com/en/data-analytics/life-sciences/epidemiology-consulting.html">
             <a:hlinkClick r:id="rId17"/>
           </p:cNvPr>
           <p:cNvSpPr/>
@@ -18951,8 +19164,8 @@
         </p:nvSpPr>
         <p:spPr>
           <a:xfrm>
-            <a:off x="9914207" y="4215244"/>
-            <a:ext cx="1200404" cy="113398"/>
+            <a:off x="9078125" y="4261613"/>
+            <a:ext cx="1823942" cy="134588"/>
           </a:xfrm>
           <a:prstGeom prst="rect">
             <a:avLst/>
@@ -19705,12 +19918,44 @@
                         <a:buNone/>
                       </a:pPr>
                       <a:r>
-                        <a:rPr lang="en-US" sz="950" dirty="0">
+                        <a:rPr lang="en-US" sz="950" dirty="0" b="1">
                           <a:solidFill>
                             <a:schemeClr val="tx1"/>
                           </a:solidFill>
                         </a:rPr>
-                        <a:t>Enriched Clinical Data; clinicogenomics datasets</a:t>
+                        <a:t>Enriched Clinical Data</a:t>
+                      </a:r>
+                      <a:r>
+                        <a:rPr lang="en-US" sz="950" dirty="0" b="0">
+                          <a:solidFill>
+                            <a:schemeClr val="tx1"/>
+                          </a:solidFill>
+                        </a:rPr>
+                        <a:t> (NLP-derived disease attributes)</a:t>
+                      </a:r>
+                      <a:r>
+                        <a:rPr lang="en-US" sz="950" dirty="0" b="0">
+                          <a:solidFill>
+                            <a:schemeClr val="tx1"/>
+                          </a:solidFill>
+                        </a:rPr>
+                        <a:t>; </a:t>
+                      </a:r>
+                      <a:r>
+                        <a:rPr lang="en-US" sz="950" dirty="0" b="1">
+                          <a:solidFill>
+                            <a:schemeClr val="tx1"/>
+                          </a:solidFill>
+                        </a:rPr>
+                        <a:t>clinicogenomics datasets</a:t>
+                      </a:r>
+                      <a:r>
+                        <a:rPr lang="en-US" sz="950" dirty="0" b="0">
+                          <a:solidFill>
+                            <a:schemeClr val="tx1"/>
+                          </a:solidFill>
+                        </a:rPr>
+                        <a:t> (linked clinical/genomic data)</a:t>
                       </a:r>
                       <a:endParaRPr lang="en-US" sz="950" dirty="0"/>
                     </a:p>
@@ -19915,12 +20160,44 @@
                         <a:buNone/>
                       </a:pPr>
                       <a:r>
-                        <a:rPr lang="en-US" sz="950" dirty="0">
+                        <a:rPr lang="en-US" sz="950" dirty="0" b="1">
                           <a:solidFill>
                             <a:schemeClr val="tx1"/>
                           </a:solidFill>
                         </a:rPr>
-                        <a:t>Clinical Notes Lab; epidemiology and observational research</a:t>
+                        <a:t>Clinical Notes Lab</a:t>
+                      </a:r>
+                      <a:r>
+                        <a:rPr lang="en-US" sz="950" dirty="0" b="0">
+                          <a:solidFill>
+                            <a:schemeClr val="tx1"/>
+                          </a:solidFill>
+                        </a:rPr>
+                        <a:t> (NLP/LLMs, custom AI models)</a:t>
+                      </a:r>
+                      <a:r>
+                        <a:rPr lang="en-US" sz="950" dirty="0" b="0">
+                          <a:solidFill>
+                            <a:schemeClr val="tx1"/>
+                          </a:solidFill>
+                        </a:rPr>
+                        <a:t>; </a:t>
+                      </a:r>
+                      <a:r>
+                        <a:rPr lang="en-US" sz="950" dirty="0" b="1">
+                          <a:solidFill>
+                            <a:schemeClr val="tx1"/>
+                          </a:solidFill>
+                        </a:rPr>
+                        <a:t>epidemiology and observational research</a:t>
+                      </a:r>
+                      <a:r>
+                        <a:rPr lang="en-US" sz="950" dirty="0" b="0">
+                          <a:solidFill>
+                            <a:schemeClr val="tx1"/>
+                          </a:solidFill>
+                        </a:rPr>
+                        <a:t> (study design, comparative effectiveness)</a:t>
                       </a:r>
                       <a:endParaRPr lang="en-US" sz="950" dirty="0"/>
                     </a:p>
@@ -20108,12 +20385,44 @@
                         <a:buNone/>
                       </a:pPr>
                       <a:r>
-                        <a:rPr lang="en-US" sz="950" dirty="0">
+                        <a:rPr lang="en-US" sz="950" dirty="0" b="1">
                           <a:solidFill>
                             <a:schemeClr val="tx1"/>
                           </a:solidFill>
                         </a:rPr>
-                        <a:t>Analytics on Demand; research data and study environments</a:t>
+                        <a:t>Analytics on Demand</a:t>
+                      </a:r>
+                      <a:r>
+                        <a:rPr lang="en-US" sz="950" dirty="0" b="0">
+                          <a:solidFill>
+                            <a:schemeClr val="tx1"/>
+                          </a:solidFill>
+                        </a:rPr>
+                        <a:t> (advanced statistical modeling, survival analysis)</a:t>
+                      </a:r>
+                      <a:r>
+                        <a:rPr lang="en-US" sz="950" dirty="0" b="0">
+                          <a:solidFill>
+                            <a:schemeClr val="tx1"/>
+                          </a:solidFill>
+                        </a:rPr>
+                        <a:t>; </a:t>
+                      </a:r>
+                      <a:r>
+                        <a:rPr lang="en-US" sz="950" dirty="0" b="1">
+                          <a:solidFill>
+                            <a:schemeClr val="tx1"/>
+                          </a:solidFill>
+                        </a:rPr>
+                        <a:t>research data and study environments</a:t>
+                      </a:r>
+                      <a:r>
+                        <a:rPr lang="en-US" sz="950" dirty="0" b="0">
+                          <a:solidFill>
+                            <a:schemeClr val="tx1"/>
+                          </a:solidFill>
+                        </a:rPr>
+                        <a:t> (curated data, analytical workspaces)</a:t>
                       </a:r>
                       <a:endParaRPr lang="en-US" sz="950" dirty="0"/>
                     </a:p>
@@ -20475,16 +20784,16 @@
       </p:sp>
       <p:sp>
         <p:nvSpPr>
-          <p:cNvPr id="28" name="Invisible source link 6: https://business.optum.com/en/data-analytics/life-">
-            <a:hlinkClick r:id="rId5"/>
+          <p:cNvPr id="30" name="Invisible source link 6: https://www.concertai.com/precision-explorer">
+            <a:hlinkClick r:id="rId7"/>
           </p:cNvPr>
           <p:cNvSpPr/>
           <p:nvPr/>
         </p:nvSpPr>
         <p:spPr>
           <a:xfrm>
-            <a:off x="8714349" y="2173681"/>
-            <a:ext cx="1176287" cy="89280"/>
+            <a:off x="3605278" y="2995561"/>
+            <a:ext cx="1056045" cy="113042"/>
           </a:xfrm>
           <a:prstGeom prst="rect">
             <a:avLst/>
@@ -20518,16 +20827,16 @@
       </p:sp>
       <p:sp>
         <p:nvSpPr>
-          <p:cNvPr id="29" name="Invisible source link 6: https://business.optum.com/en/data-analytics/life-">
-            <a:hlinkClick r:id="rId6"/>
+          <p:cNvPr id="31" name="Invisible source link 6: https://veranahealth.com/verana-health-introduces-">
+            <a:hlinkClick r:id="rId8"/>
           </p:cNvPr>
           <p:cNvSpPr/>
           <p:nvPr/>
         </p:nvSpPr>
         <p:spPr>
           <a:xfrm>
-            <a:off x="9961007" y="2173681"/>
-            <a:ext cx="1331087" cy="113042"/>
+            <a:off x="2944326" y="3182035"/>
+            <a:ext cx="848694" cy="89281"/>
           </a:xfrm>
           <a:prstGeom prst="rect">
             <a:avLst/>
@@ -20561,16 +20870,16 @@
       </p:sp>
       <p:sp>
         <p:nvSpPr>
-          <p:cNvPr id="30" name="Invisible source link 6: https://www.concertai.com/precision-explorer">
-            <a:hlinkClick r:id="rId7"/>
+          <p:cNvPr id="32" name="Invisible source link 6: https://veranahealth.com/verana-health-introduces-">
+            <a:hlinkClick r:id="rId8"/>
           </p:cNvPr>
           <p:cNvSpPr/>
           <p:nvPr/>
         </p:nvSpPr>
         <p:spPr>
           <a:xfrm>
-            <a:off x="3605278" y="2995561"/>
-            <a:ext cx="1056045" cy="113042"/>
+            <a:off x="3828110" y="3182035"/>
+            <a:ext cx="703966" cy="113398"/>
           </a:xfrm>
           <a:prstGeom prst="rect">
             <a:avLst/>
@@ -20604,16 +20913,16 @@
       </p:sp>
       <p:sp>
         <p:nvSpPr>
-          <p:cNvPr id="31" name="Invisible source link 6: https://veranahealth.com/verana-health-introduces-">
-            <a:hlinkClick r:id="rId8"/>
+          <p:cNvPr id="36" name="Invisible source link 6: https://mdclone.com/meet-copilot/">
+            <a:hlinkClick r:id="rId11"/>
           </p:cNvPr>
           <p:cNvSpPr/>
           <p:nvPr/>
         </p:nvSpPr>
         <p:spPr>
           <a:xfrm>
-            <a:off x="2944326" y="3182035"/>
-            <a:ext cx="848694" cy="89281"/>
+            <a:off x="3566759" y="3935882"/>
+            <a:ext cx="887568" cy="113398"/>
           </a:xfrm>
           <a:prstGeom prst="rect">
             <a:avLst/>
@@ -20647,16 +20956,16 @@
       </p:sp>
       <p:sp>
         <p:nvSpPr>
-          <p:cNvPr id="32" name="Invisible source link 6: https://veranahealth.com/verana-health-introduces-">
-            <a:hlinkClick r:id="rId8"/>
+          <p:cNvPr id="38" name="Invisible source link 6: https://business.optum.com/en/data-analytics/life-">
+            <a:hlinkClick r:id="rId10"/>
           </p:cNvPr>
           <p:cNvSpPr/>
           <p:nvPr/>
         </p:nvSpPr>
         <p:spPr>
           <a:xfrm>
-            <a:off x="3828110" y="3182035"/>
-            <a:ext cx="703966" cy="113398"/>
+            <a:off x="2065926" y="5418353"/>
+            <a:ext cx="1352688" cy="125641"/>
           </a:xfrm>
           <a:prstGeom prst="rect">
             <a:avLst/>
@@ -20690,16 +20999,16 @@
       </p:sp>
       <p:sp>
         <p:nvSpPr>
-          <p:cNvPr id="33" name="Invisible source link 6: https://business.optum.com/en/data-analytics/life-">
-            <a:hlinkClick r:id="rId9"/>
+          <p:cNvPr id="39" name="Invisible source link 6: https://business.optum.com/en/data-analytics/life-">
+            <a:hlinkClick r:id="rId13"/>
           </p:cNvPr>
           <p:cNvSpPr/>
           <p:nvPr/>
         </p:nvSpPr>
         <p:spPr>
           <a:xfrm>
-            <a:off x="8710742" y="3088805"/>
-            <a:ext cx="960643" cy="89280"/>
+            <a:off x="3734512" y="5418353"/>
+            <a:ext cx="1054242" cy="125641"/>
           </a:xfrm>
           <a:prstGeom prst="rect">
             <a:avLst/>
@@ -20733,16 +21042,16 @@
       </p:sp>
       <p:sp>
         <p:nvSpPr>
-          <p:cNvPr id="34" name="Invisible source link 6: https://business.optum.com/en/data-analytics/life-">
-            <a:hlinkClick r:id="rId10"/>
+          <p:cNvPr id="9508" name="Invisible source link 7: https://business.optum.com/en/data-analytics/life-sciences/real-world-data/enriched-clinical-data.html">
+            <a:hlinkClick r:id="rId5"/>
           </p:cNvPr>
           <p:cNvSpPr/>
           <p:nvPr/>
         </p:nvSpPr>
         <p:spPr>
           <a:xfrm>
-            <a:off x="9746811" y="3088792"/>
-            <a:ext cx="1761282" cy="113042"/>
+            <a:off x="8704795" y="2016291"/>
+            <a:ext cx="1269788" cy="134588"/>
           </a:xfrm>
           <a:prstGeom prst="rect">
             <a:avLst/>
@@ -20776,16 +21085,16 @@
       </p:sp>
       <p:sp>
         <p:nvSpPr>
-          <p:cNvPr id="35" name="Invisible source link 6: https://business.optum.com/en/data-analytics/life-">
-            <a:hlinkClick r:id="rId10"/>
+          <p:cNvPr id="9509" name="Invisible source link 7: https://business.optum.com/en/data-analytics/life-sciences/clinicogenomics.html">
+            <a:hlinkClick r:id="rId6"/>
           </p:cNvPr>
           <p:cNvSpPr/>
           <p:nvPr/>
         </p:nvSpPr>
         <p:spPr>
           <a:xfrm>
-            <a:off x="8709663" y="3198596"/>
-            <a:ext cx="417051" cy="89280"/>
+            <a:off x="9306725" y="2152016"/>
+            <a:ext cx="1463350" cy="134588"/>
           </a:xfrm>
           <a:prstGeom prst="rect">
             <a:avLst/>
@@ -20819,16 +21128,16 @@
       </p:sp>
       <p:sp>
         <p:nvSpPr>
-          <p:cNvPr id="36" name="Invisible source link 6: https://mdclone.com/meet-copilot/">
-            <a:hlinkClick r:id="rId11"/>
+          <p:cNvPr id="9510" name="Invisible source link 7: https://business.optum.com/en/data-analytics/life-sciences/real-world-data/clinical-notes.html">
+            <a:hlinkClick r:id="rId9"/>
           </p:cNvPr>
           <p:cNvSpPr/>
           <p:nvPr/>
         </p:nvSpPr>
         <p:spPr>
           <a:xfrm>
-            <a:off x="3566759" y="3935882"/>
-            <a:ext cx="887568" cy="113398"/>
+            <a:off x="8704795" y="2931415"/>
+            <a:ext cx="1041856" cy="134588"/>
           </a:xfrm>
           <a:prstGeom prst="rect">
             <a:avLst/>
@@ -20862,16 +21171,16 @@
       </p:sp>
       <p:sp>
         <p:nvSpPr>
-          <p:cNvPr id="37" name="Invisible source link 6: https://business.optum.com/en/data-analytics/life-">
-            <a:hlinkClick r:id="rId12"/>
+          <p:cNvPr id="9511" name="Invisible source link 7: https://business.optum.com/en/data-analytics/life-sciences/epidemiology-consulting.html">
+            <a:hlinkClick r:id="rId10"/>
           </p:cNvPr>
           <p:cNvSpPr/>
           <p:nvPr/>
         </p:nvSpPr>
         <p:spPr>
           <a:xfrm>
-            <a:off x="8704620" y="3935882"/>
-            <a:ext cx="1131648" cy="113398"/>
+            <a:off x="8704795" y="3067140"/>
+            <a:ext cx="2372186" cy="134588"/>
           </a:xfrm>
           <a:prstGeom prst="rect">
             <a:avLst/>
@@ -20905,59 +21214,16 @@
       </p:sp>
       <p:sp>
         <p:nvSpPr>
-          <p:cNvPr id="38" name="Invisible source link 6: https://business.optum.com/en/data-analytics/life-">
-            <a:hlinkClick r:id="rId10"/>
+          <p:cNvPr id="9512" name="Invisible source link 7: https://business.optum.com/en/data-analytics/life-sciences/heor/exploratory-analysis.html">
+            <a:hlinkClick r:id="rId12"/>
           </p:cNvPr>
           <p:cNvSpPr/>
           <p:nvPr/>
         </p:nvSpPr>
         <p:spPr>
           <a:xfrm>
-            <a:off x="2065926" y="5418353"/>
-            <a:ext cx="1352688" cy="125641"/>
-          </a:xfrm>
-          <a:prstGeom prst="rect">
-            <a:avLst/>
-          </a:prstGeom>
-          <a:noFill/>
-          <a:ln>
-            <a:noFill/>
-          </a:ln>
-        </p:spPr>
-        <p:style>
-          <a:lnRef idx="1">
-            <a:schemeClr val="accent1"/>
-          </a:lnRef>
-          <a:fillRef idx="3">
-            <a:schemeClr val="accent1"/>
-          </a:fillRef>
-          <a:effectRef idx="2">
-            <a:schemeClr val="accent1"/>
-          </a:effectRef>
-          <a:fontRef idx="minor">
-            <a:schemeClr val="lt1"/>
-          </a:fontRef>
-        </p:style>
-        <p:txBody>
-          <a:bodyPr rtlCol="0" anchor="ctr"/>
-          <a:lstStyle/>
-          <a:p>
-            <a:pPr algn="ctr"/>
-          </a:p>
-        </p:txBody>
-      </p:sp>
-      <p:sp>
-        <p:nvSpPr>
-          <p:cNvPr id="39" name="Invisible source link 6: https://business.optum.com/en/data-analytics/life-">
-            <a:hlinkClick r:id="rId13"/>
-          </p:cNvPr>
-          <p:cNvSpPr/>
-          <p:nvPr/>
-        </p:nvSpPr>
-        <p:spPr>
-          <a:xfrm>
-            <a:off x="3734512" y="5418353"/>
-            <a:ext cx="1054242" cy="125641"/>
+            <a:off x="8704795" y="3778492"/>
+            <a:ext cx="1222996" cy="134588"/>
           </a:xfrm>
           <a:prstGeom prst="rect">
             <a:avLst/>
@@ -21789,12 +22055,20 @@
                         <a:buNone/>
                       </a:pPr>
                       <a:r>
-                        <a:rPr lang="en-US" sz="950" dirty="0">
+                        <a:rPr lang="en-US" sz="950" dirty="0" b="1">
                           <a:solidFill>
                             <a:schemeClr val="tx1"/>
                           </a:solidFill>
                         </a:rPr>
-                        <a:t>Market Clarity: market attractiveness and portfolio research</a:t>
+                        <a:t>Market Clarity</a:t>
+                      </a:r>
+                      <a:r>
+                        <a:rPr lang="en-US" sz="950" dirty="0" b="0">
+                          <a:solidFill>
+                            <a:schemeClr val="tx1"/>
+                          </a:solidFill>
+                        </a:rPr>
+                        <a:t> (linked claims/EHR data, market attractiveness and portfolio analytics)</a:t>
                       </a:r>
                       <a:endParaRPr lang="en-US" sz="950" dirty="0"/>
                     </a:p>
@@ -22048,12 +22322,20 @@
                         <a:buNone/>
                       </a:pPr>
                       <a:r>
-                        <a:rPr lang="en-US" sz="950" dirty="0">
+                        <a:rPr lang="en-US" sz="950" dirty="0" b="1">
                           <a:solidFill>
                             <a:schemeClr val="tx1"/>
                           </a:solidFill>
                         </a:rPr>
-                        <a:t>Market Clarity: patient and prescriber analytics</a:t>
+                        <a:t>Market Clarity</a:t>
+                      </a:r>
+                      <a:r>
+                        <a:rPr lang="en-US" sz="950" dirty="0" b="0">
+                          <a:solidFill>
+                            <a:schemeClr val="tx1"/>
+                          </a:solidFill>
+                        </a:rPr>
+                        <a:t> (patient/prescriber segmentation, treatment patterns, market analytics)</a:t>
                       </a:r>
                       <a:endParaRPr lang="en-US" sz="950" dirty="0"/>
                     </a:p>
@@ -22268,12 +22550,36 @@
                         <a:buNone/>
                       </a:pPr>
                       <a:r>
-                        <a:rPr lang="en-US" sz="950" dirty="0">
+                        <a:rPr lang="en-US" sz="950" dirty="0" b="1">
                           <a:solidFill>
                             <a:schemeClr val="tx1"/>
                           </a:solidFill>
                         </a:rPr>
-                        <a:t>Market Clarity provides market insights; a directly comparable simulated-persona offering was not established in the Optum review</a:t>
+                        <a:t>Market Clarity</a:t>
+                      </a:r>
+                      <a:r>
+                        <a:rPr lang="en-US" sz="950" dirty="0" b="0">
+                          <a:solidFill>
+                            <a:schemeClr val="tx1"/>
+                          </a:solidFill>
+                        </a:rPr>
+                        <a:t> (observed patient/prescriber insights)</a:t>
+                      </a:r>
+                      <a:r>
+                        <a:rPr lang="en-US" sz="950" dirty="0" b="0">
+                          <a:solidFill>
+                            <a:schemeClr val="tx1"/>
+                          </a:solidFill>
+                        </a:rPr>
+                        <a:t>; </a:t>
+                      </a:r>
+                      <a:r>
+                        <a:rPr lang="en-US" sz="950" dirty="0" b="0">
+                          <a:solidFill>
+                            <a:schemeClr val="tx1"/>
+                          </a:solidFill>
+                        </a:rPr>
+                        <a:t>no comparable simulated-persona offering established</a:t>
                       </a:r>
                       <a:endParaRPr lang="en-US" sz="950" dirty="0"/>
                     </a:p>
@@ -22729,16 +23035,16 @@
       </p:sp>
       <p:sp>
         <p:nvSpPr>
-          <p:cNvPr id="30" name="Invisible source link 7: https://business.optum.com/en/data-analytics/life-">
-            <a:hlinkClick r:id="rId6"/>
+          <p:cNvPr id="31" name="Invisible source link 7: https://www.iqvia.com/solutions/commercialization/">
+            <a:hlinkClick r:id="rId3"/>
           </p:cNvPr>
           <p:cNvSpPr/>
           <p:nvPr/>
         </p:nvSpPr>
         <p:spPr>
           <a:xfrm>
-            <a:off x="8714349" y="2194559"/>
-            <a:ext cx="734204" cy="113398"/>
+            <a:off x="3382433" y="3003486"/>
+            <a:ext cx="1005652" cy="113753"/>
           </a:xfrm>
           <a:prstGeom prst="rect">
             <a:avLst/>
@@ -22772,16 +23078,16 @@
       </p:sp>
       <p:sp>
         <p:nvSpPr>
-          <p:cNvPr id="31" name="Invisible source link 7: https://www.iqvia.com/solutions/commercialization/">
-            <a:hlinkClick r:id="rId3"/>
+          <p:cNvPr id="32" name="Invisible source link 7: https://zaidyn.zs.com/products/zaidyn-commercial/c">
+            <a:hlinkClick r:id="rId7"/>
           </p:cNvPr>
           <p:cNvSpPr/>
           <p:nvPr/>
         </p:nvSpPr>
         <p:spPr>
           <a:xfrm>
-            <a:off x="3382433" y="3003486"/>
-            <a:ext cx="1005652" cy="113753"/>
+            <a:off x="3219354" y="3189960"/>
+            <a:ext cx="2410360" cy="89280"/>
           </a:xfrm>
           <a:prstGeom prst="rect">
             <a:avLst/>
@@ -22815,16 +23121,16 @@
       </p:sp>
       <p:sp>
         <p:nvSpPr>
-          <p:cNvPr id="32" name="Invisible source link 7: https://zaidyn.zs.com/products/zaidyn-commercial/c">
-            <a:hlinkClick r:id="rId7"/>
+          <p:cNvPr id="33" name="Invisible source link 7: https://close-upinternational.com/es/crm-farmaceut">
+            <a:hlinkClick r:id="rId8"/>
           </p:cNvPr>
           <p:cNvSpPr/>
           <p:nvPr/>
         </p:nvSpPr>
         <p:spPr>
           <a:xfrm>
-            <a:off x="3219354" y="3189960"/>
-            <a:ext cx="2410360" cy="89280"/>
+            <a:off x="4260833" y="3376447"/>
+            <a:ext cx="516770" cy="113398"/>
           </a:xfrm>
           <a:prstGeom prst="rect">
             <a:avLst/>
@@ -22858,16 +23164,16 @@
       </p:sp>
       <p:sp>
         <p:nvSpPr>
-          <p:cNvPr id="33" name="Invisible source link 7: https://close-upinternational.com/es/crm-farmaceut">
-            <a:hlinkClick r:id="rId8"/>
+          <p:cNvPr id="35" name="Invisible source link 7: https://trinitylifesciences.com/products/insightse">
+            <a:hlinkClick r:id="rId9"/>
           </p:cNvPr>
           <p:cNvSpPr/>
           <p:nvPr/>
         </p:nvSpPr>
         <p:spPr>
           <a:xfrm>
-            <a:off x="4260833" y="3376447"/>
-            <a:ext cx="516770" cy="113398"/>
+            <a:off x="4080469" y="4105084"/>
+            <a:ext cx="1560764" cy="113754"/>
           </a:xfrm>
           <a:prstGeom prst="rect">
             <a:avLst/>
@@ -22901,16 +23207,16 @@
       </p:sp>
       <p:sp>
         <p:nvSpPr>
-          <p:cNvPr id="34" name="Invisible source link 7: https://business.optum.com/en/data-analytics/life-">
-            <a:hlinkClick r:id="rId6"/>
+          <p:cNvPr id="36" name="Invisible source link 7: https://www.ipsos.com/en/healthcare/healthcare-per">
+            <a:hlinkClick r:id="rId10"/>
           </p:cNvPr>
           <p:cNvSpPr/>
           <p:nvPr/>
         </p:nvSpPr>
         <p:spPr>
           <a:xfrm>
-            <a:off x="8714349" y="3257994"/>
-            <a:ext cx="734204" cy="113042"/>
+            <a:off x="3357961" y="4291558"/>
+            <a:ext cx="1317764" cy="89280"/>
           </a:xfrm>
           <a:prstGeom prst="rect">
             <a:avLst/>
@@ -22944,16 +23250,16 @@
       </p:sp>
       <p:sp>
         <p:nvSpPr>
-          <p:cNvPr id="35" name="Invisible source link 7: https://trinitylifesciences.com/products/insightse">
-            <a:hlinkClick r:id="rId9"/>
+          <p:cNvPr id="9513" name="Invisible source link 8: https://business.optum.com/en/data-analytics/life-sciences/real-world-data/market-clarity-data.html">
+            <a:hlinkClick r:id="rId6"/>
           </p:cNvPr>
           <p:cNvSpPr/>
           <p:nvPr/>
         </p:nvSpPr>
         <p:spPr>
           <a:xfrm>
-            <a:off x="4080469" y="4105084"/>
-            <a:ext cx="1560764" cy="113754"/>
+            <a:off x="8704795" y="2172895"/>
+            <a:ext cx="794989" cy="134588"/>
           </a:xfrm>
           <a:prstGeom prst="rect">
             <a:avLst/>
@@ -22987,16 +23293,16 @@
       </p:sp>
       <p:sp>
         <p:nvSpPr>
-          <p:cNvPr id="36" name="Invisible source link 7: https://www.ipsos.com/en/healthcare/healthcare-per">
-            <a:hlinkClick r:id="rId10"/>
+          <p:cNvPr id="9514" name="Invisible source link 8: https://business.optum.com/en/data-analytics/life-sciences/real-world-data/market-clarity-data.html">
+            <a:hlinkClick r:id="rId6"/>
           </p:cNvPr>
           <p:cNvSpPr/>
           <p:nvPr/>
         </p:nvSpPr>
         <p:spPr>
           <a:xfrm>
-            <a:off x="3357961" y="4291558"/>
-            <a:ext cx="1317764" cy="89280"/>
+            <a:off x="8704795" y="3168295"/>
+            <a:ext cx="794989" cy="134588"/>
           </a:xfrm>
           <a:prstGeom prst="rect">
             <a:avLst/>
@@ -23030,7 +23336,7 @@
       </p:sp>
       <p:sp>
         <p:nvSpPr>
-          <p:cNvPr id="37" name="Invisible source link 7: https://business.optum.com/en/data-analytics/life-">
+          <p:cNvPr id="9515" name="Invisible source link 8: https://business.optum.com/en/data-analytics/life-sciences/real-world-data/market-clarity-data.html">
             <a:hlinkClick r:id="rId6"/>
           </p:cNvPr>
           <p:cNvSpPr/>
@@ -23038,8 +23344,8 @@
         </p:nvSpPr>
         <p:spPr>
           <a:xfrm>
-            <a:off x="8714349" y="4062603"/>
-            <a:ext cx="734204" cy="113398"/>
+            <a:off x="8704795" y="4040938"/>
+            <a:ext cx="794989" cy="134588"/>
           </a:xfrm>
           <a:prstGeom prst="rect">
             <a:avLst/>
@@ -23753,12 +24059,44 @@
                         <a:buNone/>
                       </a:pPr>
                       <a:r>
-                        <a:rPr lang="en-US" sz="950" dirty="0">
+                        <a:rPr lang="en-US" sz="950" dirty="0" b="1">
                           <a:solidFill>
                             <a:schemeClr val="tx1"/>
                           </a:solidFill>
                         </a:rPr>
-                        <a:t>Epidemiology research; postapproval safety and comparative-effectiveness studies</a:t>
+                        <a:t>Epidemiology research</a:t>
+                      </a:r>
+                      <a:r>
+                        <a:rPr lang="en-US" sz="950" dirty="0" b="0">
+                          <a:solidFill>
+                            <a:schemeClr val="tx1"/>
+                          </a:solidFill>
+                        </a:rPr>
+                        <a:t> (study design, RWE generation)</a:t>
+                      </a:r>
+                      <a:r>
+                        <a:rPr lang="en-US" sz="950" dirty="0" b="0">
+                          <a:solidFill>
+                            <a:schemeClr val="tx1"/>
+                          </a:solidFill>
+                        </a:rPr>
+                        <a:t>; </a:t>
+                      </a:r>
+                      <a:r>
+                        <a:rPr lang="en-US" sz="950" dirty="0" b="1">
+                          <a:solidFill>
+                            <a:schemeClr val="tx1"/>
+                          </a:solidFill>
+                        </a:rPr>
+                        <a:t>postapproval safety and comparative-effectiveness studies</a:t>
+                      </a:r>
+                      <a:r>
+                        <a:rPr lang="en-US" sz="950" dirty="0" b="0">
+                          <a:solidFill>
+                            <a:schemeClr val="tx1"/>
+                          </a:solidFill>
+                        </a:rPr>
+                        <a:t> (statistical analysis)</a:t>
                       </a:r>
                       <a:endParaRPr lang="en-US" sz="950" dirty="0"/>
                     </a:p>
@@ -23985,12 +24323,20 @@
                         <a:buNone/>
                       </a:pPr>
                       <a:r>
-                        <a:rPr lang="en-US" sz="950" dirty="0">
+                        <a:rPr lang="en-US" sz="950" dirty="0" b="1">
                           <a:solidFill>
                             <a:schemeClr val="tx1"/>
                           </a:solidFill>
                         </a:rPr>
-                        <a:t>Market Clarity medical affairs evidence and MSL insights</a:t>
+                        <a:t>Market Clarity</a:t>
+                      </a:r>
+                      <a:r>
+                        <a:rPr lang="en-US" sz="950" dirty="0" b="0">
+                          <a:solidFill>
+                            <a:schemeClr val="tx1"/>
+                          </a:solidFill>
+                        </a:rPr>
+                        <a:t> (medical affairs evidence, MSL insights, HCP analytics)</a:t>
                       </a:r>
                       <a:endParaRPr lang="en-US" sz="950" dirty="0"/>
                     </a:p>
@@ -24156,12 +24502,36 @@
                         <a:buNone/>
                       </a:pPr>
                       <a:r>
-                        <a:rPr lang="en-US" sz="950" dirty="0">
+                        <a:rPr lang="en-US" sz="950" dirty="0" b="1">
                           <a:solidFill>
                             <a:schemeClr val="tx1"/>
                           </a:solidFill>
                         </a:rPr>
-                        <a:t>Optum's safety and evidence-research services are adjacent; a comparable conversational interface for regulated documents was not established</a:t>
+                        <a:t>Safety and evidence-research services</a:t>
+                      </a:r>
+                      <a:r>
+                        <a:rPr lang="en-US" sz="950" dirty="0" b="0">
+                          <a:solidFill>
+                            <a:schemeClr val="tx1"/>
+                          </a:solidFill>
+                        </a:rPr>
+                        <a:t> (scientific analysis)</a:t>
+                      </a:r>
+                      <a:r>
+                        <a:rPr lang="en-US" sz="950" dirty="0" b="0">
+                          <a:solidFill>
+                            <a:schemeClr val="tx1"/>
+                          </a:solidFill>
+                        </a:rPr>
+                        <a:t>; </a:t>
+                      </a:r>
+                      <a:r>
+                        <a:rPr lang="en-US" sz="950" dirty="0" b="0">
+                          <a:solidFill>
+                            <a:schemeClr val="tx1"/>
+                          </a:solidFill>
+                        </a:rPr>
+                        <a:t>no comparable regulated-document assistant established</a:t>
                       </a:r>
                       <a:endParaRPr lang="en-US" sz="950" dirty="0"/>
                     </a:p>
@@ -24381,16 +24751,16 @@
       </p:sp>
       <p:sp>
         <p:nvSpPr>
-          <p:cNvPr id="27" name="Invisible source link 8: https://business.optum.com/en/data-analytics/life-">
-            <a:hlinkClick r:id="rId4"/>
+          <p:cNvPr id="29" name="Invisible source link 8: https://zaidyn.zs.com/products/zaidyn-medical/conv">
+            <a:hlinkClick r:id="rId5"/>
           </p:cNvPr>
           <p:cNvSpPr/>
           <p:nvPr/>
         </p:nvSpPr>
         <p:spPr>
           <a:xfrm>
-            <a:off x="8714349" y="2141283"/>
-            <a:ext cx="1209040" cy="113398"/>
+            <a:off x="3217564" y="3012833"/>
+            <a:ext cx="2162318" cy="89280"/>
           </a:xfrm>
           <a:prstGeom prst="rect">
             <a:avLst/>
@@ -24424,16 +24794,16 @@
       </p:sp>
       <p:sp>
         <p:nvSpPr>
-          <p:cNvPr id="28" name="Invisible source link 8: https://business.optum.com/en/data-analytics/life-">
-            <a:hlinkClick r:id="rId4"/>
+          <p:cNvPr id="30" name="Invisible source link 8: https://evidenze.com/">
+            <a:hlinkClick r:id="rId6"/>
           </p:cNvPr>
           <p:cNvSpPr/>
           <p:nvPr/>
         </p:nvSpPr>
         <p:spPr>
           <a:xfrm>
-            <a:off x="10003856" y="2141283"/>
-            <a:ext cx="1038049" cy="113398"/>
+            <a:off x="3558835" y="3335032"/>
+            <a:ext cx="1742562" cy="89280"/>
           </a:xfrm>
           <a:prstGeom prst="rect">
             <a:avLst/>
@@ -24467,16 +24837,16 @@
       </p:sp>
       <p:sp>
         <p:nvSpPr>
-          <p:cNvPr id="29" name="Invisible source link 8: https://zaidyn.zs.com/products/zaidyn-medical/conv">
-            <a:hlinkClick r:id="rId5"/>
+          <p:cNvPr id="32" name="Invisible source link 8: https://platform.veevavault.help/en/lr/950642">
+            <a:hlinkClick r:id="rId8"/>
           </p:cNvPr>
           <p:cNvSpPr/>
           <p:nvPr/>
         </p:nvSpPr>
         <p:spPr>
           <a:xfrm>
-            <a:off x="3217564" y="3012833"/>
-            <a:ext cx="2162318" cy="89280"/>
+            <a:off x="3396111" y="4249077"/>
+            <a:ext cx="738167" cy="89280"/>
           </a:xfrm>
           <a:prstGeom prst="rect">
             <a:avLst/>
@@ -24510,16 +24880,16 @@
       </p:sp>
       <p:sp>
         <p:nvSpPr>
-          <p:cNvPr id="30" name="Invisible source link 8: https://evidenze.com/">
-            <a:hlinkClick r:id="rId6"/>
+          <p:cNvPr id="9516" name="Invisible source link 9: https://business.optum.com/en/data-analytics/life-sciences/epidemiology-consulting.html">
+            <a:hlinkClick r:id="rId4"/>
           </p:cNvPr>
           <p:cNvSpPr/>
           <p:nvPr/>
         </p:nvSpPr>
         <p:spPr>
           <a:xfrm>
-            <a:off x="3558835" y="3335032"/>
-            <a:ext cx="1742562" cy="89280"/>
+            <a:off x="8704795" y="1983893"/>
+            <a:ext cx="1323576" cy="134588"/>
           </a:xfrm>
           <a:prstGeom prst="rect">
             <a:avLst/>
@@ -24553,16 +24923,16 @@
       </p:sp>
       <p:sp>
         <p:nvSpPr>
-          <p:cNvPr id="31" name="Invisible source link 8: https://business.optum.com/en/data-analytics/life-">
-            <a:hlinkClick r:id="rId7"/>
+          <p:cNvPr id="9517" name="Invisible source link 9: https://business.optum.com/en/data-analytics/life-sciences/epidemiology-consulting.html">
+            <a:hlinkClick r:id="rId4"/>
           </p:cNvPr>
           <p:cNvSpPr/>
           <p:nvPr/>
         </p:nvSpPr>
         <p:spPr>
           <a:xfrm>
-            <a:off x="8714349" y="3173755"/>
-            <a:ext cx="734204" cy="113398"/>
+            <a:off x="9379800" y="2119618"/>
+            <a:ext cx="1383152" cy="134588"/>
           </a:xfrm>
           <a:prstGeom prst="rect">
             <a:avLst/>
@@ -24596,16 +24966,59 @@
       </p:sp>
       <p:sp>
         <p:nvSpPr>
-          <p:cNvPr id="32" name="Invisible source link 8: https://platform.veevavault.help/en/lr/950642">
-            <a:hlinkClick r:id="rId8"/>
+          <p:cNvPr id="9518" name="Invisible source link 9: https://business.optum.com/en/data-analytics/life-sciences/epidemiology-consulting.html">
+            <a:hlinkClick r:id="rId4"/>
           </p:cNvPr>
           <p:cNvSpPr/>
           <p:nvPr/>
         </p:nvSpPr>
         <p:spPr>
           <a:xfrm>
-            <a:off x="3396111" y="4249077"/>
-            <a:ext cx="738167" cy="89280"/>
+            <a:off x="8704795" y="2255343"/>
+            <a:ext cx="1964199" cy="134588"/>
+          </a:xfrm>
+          <a:prstGeom prst="rect">
+            <a:avLst/>
+          </a:prstGeom>
+          <a:noFill/>
+          <a:ln>
+            <a:noFill/>
+          </a:ln>
+        </p:spPr>
+        <p:style>
+          <a:lnRef idx="1">
+            <a:schemeClr val="accent1"/>
+          </a:lnRef>
+          <a:fillRef idx="3">
+            <a:schemeClr val="accent1"/>
+          </a:fillRef>
+          <a:effectRef idx="2">
+            <a:schemeClr val="accent1"/>
+          </a:effectRef>
+          <a:fontRef idx="minor">
+            <a:schemeClr val="lt1"/>
+          </a:fontRef>
+        </p:style>
+        <p:txBody>
+          <a:bodyPr rtlCol="0" anchor="ctr"/>
+          <a:lstStyle/>
+          <a:p>
+            <a:pPr algn="ctr"/>
+          </a:p>
+        </p:txBody>
+      </p:sp>
+      <p:sp>
+        <p:nvSpPr>
+          <p:cNvPr id="9519" name="Invisible source link 9: https://business.optum.com/en/data-analytics/life-sciences/real-world-data/market-clarity-data.html">
+            <a:hlinkClick r:id="rId7"/>
+          </p:cNvPr>
+          <p:cNvSpPr/>
+          <p:nvPr/>
+        </p:nvSpPr>
+        <p:spPr>
+          <a:xfrm>
+            <a:off x="8704795" y="3152103"/>
+            <a:ext cx="794989" cy="134588"/>
           </a:xfrm>
           <a:prstGeom prst="rect">
             <a:avLst/>

</xml_diff>

<commit_message>
Page 6: update RWE competitor descriptions and split bottom card into two observations
Co-Authored-By: Claude Opus 5.5 <noreply@anthropic.com>
Claude-Session: https://claude.ai/code/session_0198bm9pfzRwgZQBqNvd56W8
</commit_message>
<xml_diff>
--- a/deck/Optum-LS-Conversational-AI-sourced.pptx
+++ b/deck/Optum-LS-Conversational-AI-sourced.pptx
@@ -17004,6 +17004,10 @@
           </a:solidFill>
           <a:ln/>
         </p:spPr>
+        <p:txBody>
+          <a:bodyPr/>
+          <a:p/>
+        </p:txBody>
       </p:sp>
       <p:sp>
         <p:nvSpPr>
@@ -17062,6 +17066,10 @@
           </a:solidFill>
           <a:ln/>
         </p:spPr>
+        <p:txBody>
+          <a:bodyPr/>
+          <a:p/>
+        </p:txBody>
       </p:sp>
       <p:sp>
         <p:nvSpPr>
@@ -17120,6 +17128,10 @@
           </a:solidFill>
           <a:ln/>
         </p:spPr>
+        <p:txBody>
+          <a:bodyPr/>
+          <a:p/>
+        </p:txBody>
       </p:sp>
       <p:sp>
         <p:nvSpPr>
@@ -17178,6 +17190,10 @@
           </a:solidFill>
           <a:ln/>
         </p:spPr>
+        <p:txBody>
+          <a:bodyPr/>
+          <a:p/>
+        </p:txBody>
       </p:sp>
       <p:sp>
         <p:nvSpPr>
@@ -17236,6 +17252,10 @@
           </a:solidFill>
           <a:ln/>
         </p:spPr>
+        <p:txBody>
+          <a:bodyPr/>
+          <a:p/>
+        </p:txBody>
       </p:sp>
       <p:sp>
         <p:nvSpPr>
@@ -17539,25 +17559,9 @@
                       <a:pPr indent="0" marL="0">
                         <a:buNone/>
                       </a:pPr>
-                      <a:r>
-                        <a:rPr lang="en-US" sz="950" dirty="0">
-                          <a:solidFill>
-                            <a:schemeClr val="tx1"/>
-                          </a:solidFill>
-                        </a:rPr>
-                        <a:t>Merative’s </a:t>
-                      </a:r>
                       <a:pPr indent="0" marL="0">
                         <a:buNone/>
                       </a:pPr>
-                      <a:r>
-                        <a:rPr lang="en-US" sz="950" b="1" dirty="0">
-                          <a:solidFill>
-                            <a:schemeClr val="tx1"/>
-                          </a:solidFill>
-                        </a:rPr>
-                        <a:t>MarketScan Snapshot</a:t>
-                      </a:r>
                       <a:pPr indent="0" marL="0">
                         <a:buNone/>
                       </a:pPr>
@@ -17567,7 +17571,23 @@
                             <a:schemeClr val="tx1"/>
                           </a:solidFill>
                         </a:rPr>
-                        <a:t>: natural-language assessment of dataset suitability;</a:t>
+                        <a:t>Truven </a:t>
+                      </a:r>
+                      <a:r>
+                        <a:rPr lang="en-US" sz="950" b="1" dirty="0">
+                          <a:solidFill>
+                            <a:schemeClr val="tx1"/>
+                          </a:solidFill>
+                        </a:rPr>
+                        <a:t>MarketScan Snapshot</a:t>
+                      </a:r>
+                      <a:r>
+                        <a:rPr lang="en-US" sz="950" dirty="0">
+                          <a:solidFill>
+                            <a:schemeClr val="tx1"/>
+                          </a:solidFill>
+                        </a:rPr>
+                        <a:t>: Natural-language assessment of MarketScan data suitability;</a:t>
                       </a:r>
                       <a:endParaRPr lang="en-US" sz="950" dirty="0"/>
                     </a:p>
@@ -17578,25 +17598,9 @@
                         </a:spcBef>
                         <a:buNone/>
                       </a:pPr>
-                      <a:r>
-                        <a:rPr lang="en-US" sz="950" dirty="0">
-                          <a:solidFill>
-                            <a:schemeClr val="tx1"/>
-                          </a:solidFill>
-                        </a:rPr>
-                        <a:t>HealthVerity’s </a:t>
-                      </a:r>
                       <a:pPr indent="0" marL="0">
                         <a:buNone/>
                       </a:pPr>
-                      <a:r>
-                        <a:rPr lang="en-US" sz="950" b="1" dirty="0">
-                          <a:solidFill>
-                            <a:schemeClr val="tx1"/>
-                          </a:solidFill>
-                        </a:rPr>
-                        <a:t>eXOs</a:t>
-                      </a:r>
                       <a:pPr indent="0" marL="0">
                         <a:buNone/>
                       </a:pPr>
@@ -17606,7 +17610,23 @@
                             <a:schemeClr val="tx1"/>
                           </a:solidFill>
                         </a:rPr>
-                        <a:t>: conversational exploration of connected healthcare data</a:t>
+                        <a:t>Norstella / Panalgo </a:t>
+                      </a:r>
+                      <a:r>
+                        <a:rPr lang="en-US" sz="950" b="1" dirty="0">
+                          <a:solidFill>
+                            <a:schemeClr val="tx1"/>
+                          </a:solidFill>
+                        </a:rPr>
+                        <a:t>Ella AI</a:t>
+                      </a:r>
+                      <a:r>
+                        <a:rPr lang="en-US" sz="950" dirty="0">
+                          <a:solidFill>
+                            <a:schemeClr val="tx1"/>
+                          </a:solidFill>
+                        </a:rPr>
+                        <a:t>: Conversational dataset recommendations (along with cohort construction and documented RWE analysis)</a:t>
                       </a:r>
                       <a:endParaRPr lang="en-US" sz="950" dirty="0"/>
                     </a:p>
@@ -18130,25 +18150,9 @@
                       <a:pPr indent="0" marL="0">
                         <a:buNone/>
                       </a:pPr>
-                      <a:r>
-                        <a:rPr lang="en-US" sz="950" dirty="0">
-                          <a:solidFill>
-                            <a:schemeClr val="tx1"/>
-                          </a:solidFill>
-                        </a:rPr>
-                        <a:t>Norstella’s </a:t>
-                      </a:r>
                       <a:pPr indent="0" marL="0">
                         <a:buNone/>
                       </a:pPr>
-                      <a:r>
-                        <a:rPr lang="en-US" sz="950" b="1" dirty="0">
-                          <a:solidFill>
-                            <a:schemeClr val="tx1"/>
-                          </a:solidFill>
-                        </a:rPr>
-                        <a:t>Ella AI</a:t>
-                      </a:r>
                       <a:pPr indent="0" marL="0">
                         <a:buNone/>
                       </a:pPr>
@@ -18158,7 +18162,23 @@
                             <a:schemeClr val="tx1"/>
                           </a:solidFill>
                         </a:rPr>
-                        <a:t>: conversational RWE analytics;</a:t>
+                        <a:t>HealthVerity </a:t>
+                      </a:r>
+                      <a:r>
+                        <a:rPr lang="en-US" sz="950" b="1" dirty="0">
+                          <a:solidFill>
+                            <a:schemeClr val="tx1"/>
+                          </a:solidFill>
+                        </a:rPr>
+                        <a:t>eXOs</a:t>
+                      </a:r>
+                      <a:r>
+                        <a:rPr lang="en-US" sz="950" dirty="0">
+                          <a:solidFill>
+                            <a:schemeClr val="tx1"/>
+                          </a:solidFill>
+                        </a:rPr>
+                        <a:t>: Conversational data feasibility, cohort design and auditable RWE analysis;</a:t>
                       </a:r>
                       <a:endParaRPr lang="en-US" sz="950" dirty="0"/>
                     </a:p>
@@ -18324,14 +18344,14 @@
       </p:graphicFrame>
       <p:sp>
         <p:nvSpPr>
-          <p:cNvPr id="15" name="beyond the public evidence card"/>
+          <p:cNvPr id="15" name="end-to-end conversational rwe card"/>
           <p:cNvSpPr/>
           <p:nvPr/>
         </p:nvSpPr>
         <p:spPr>
           <a:xfrm>
             <a:off x="548640" y="5033010"/>
-            <a:ext cx="11091672" cy="1020318"/>
+            <a:ext cx="5454396" cy="1020318"/>
           </a:xfrm>
           <a:prstGeom prst="rect">
             <a:avLst/>
@@ -18348,6 +18368,10 @@
             </a:outerShdw>
           </a:effectLst>
         </p:spPr>
+        <p:txBody>
+          <a:bodyPr/>
+          <a:p/>
+        </p:txBody>
       </p:sp>
       <p:sp>
         <p:nvSpPr>
@@ -18357,8 +18381,8 @@
         </p:nvSpPr>
         <p:spPr>
           <a:xfrm>
-            <a:off x="749808" y="5215890"/>
-            <a:ext cx="10689336" cy="256032"/>
+            <a:off x="749808" y="5095113"/>
+            <a:ext cx="5052060" cy="256032"/>
           </a:xfrm>
           <a:prstGeom prst="rect">
             <a:avLst/>
@@ -18379,7 +18403,7 @@
                   <a:schemeClr val="accent2"/>
                 </a:solidFill>
               </a:rPr>
-              <a:t>BEYOND THE PUBLIC EVIDENCE</a:t>
+              <a:t>END-TO-END CONVERSATIONAL RWE</a:t>
             </a:r>
             <a:endParaRPr lang="en-US" sz="1300" dirty="0"/>
           </a:p>
@@ -18393,8 +18417,8 @@
         </p:nvSpPr>
         <p:spPr>
           <a:xfrm>
-            <a:off x="749808" y="5545074"/>
-            <a:ext cx="10689336" cy="380238"/>
+            <a:off x="749808" y="5424297"/>
+            <a:ext cx="5052060" cy="566928"/>
           </a:xfrm>
           <a:prstGeom prst="rect">
             <a:avLst/>
@@ -18415,7 +18439,7 @@
                   <a:schemeClr val="tx1"/>
                 </a:solidFill>
               </a:rPr>
-              <a:t>What information can researchers query directly? What outputs can they generate, inspect and reuse? Where do dataset permissions, cohort definitions or specialist involvement constrain the experience?</a:t>
+              <a:t>HealthVerity eXOs and Norstella Ella position conversational AI as the front door to their platforms, spanning dataset assessment, cohort exploration and broader research questions in a single chat workflow.</a:t>
             </a:r>
             <a:endParaRPr lang="en-US" sz="1050" dirty="0"/>
           </a:p>
@@ -18468,16 +18492,16 @@
       </p:sp>
       <p:sp>
         <p:nvSpPr>
-          <p:cNvPr id="26" name="Invisible source link 5: https://www.merative.com/newsroom/truven-launches-">
-            <a:hlinkClick r:id="rId3"/>
+          <p:cNvPr id="33" name="Invisible source link 5: https://www.komodohealth.com/product/marmot/">
+            <a:hlinkClick r:id="rId8"/>
           </p:cNvPr>
           <p:cNvSpPr/>
           <p:nvPr/>
         </p:nvSpPr>
         <p:spPr>
           <a:xfrm>
-            <a:off x="3531835" y="2122195"/>
-            <a:ext cx="1250810" cy="113398"/>
+            <a:off x="3900118" y="3032277"/>
+            <a:ext cx="426779" cy="84963"/>
           </a:xfrm>
           <a:prstGeom prst="rect">
             <a:avLst/>
@@ -18511,16 +18535,16 @@
       </p:sp>
       <p:sp>
         <p:nvSpPr>
-          <p:cNvPr id="27" name="Invisible source link 5: https://healthverity.com/news/announcing-healthver">
-            <a:hlinkClick r:id="rId4"/>
+          <p:cNvPr id="34" name="Invisible source link 5: https://www.komodohealth.com/press/komodo-health-u">
+            <a:hlinkClick r:id="rId9"/>
           </p:cNvPr>
           <p:cNvSpPr/>
           <p:nvPr/>
         </p:nvSpPr>
         <p:spPr>
           <a:xfrm>
-            <a:off x="2953686" y="2308682"/>
-            <a:ext cx="725569" cy="113398"/>
+            <a:off x="4602828" y="3032277"/>
+            <a:ext cx="346490" cy="108724"/>
           </a:xfrm>
           <a:prstGeom prst="rect">
             <a:avLst/>
@@ -18554,16 +18578,16 @@
       </p:sp>
       <p:sp>
         <p:nvSpPr>
-          <p:cNvPr id="28" name="Invisible source link 5: https://healthverity.com/news/announcing-healthver">
-            <a:hlinkClick r:id="rId4"/>
+          <p:cNvPr id="35" name="Invisible source link 5: https://www.truveta.com/blog/announcement/truveta-">
+            <a:hlinkClick r:id="rId10"/>
           </p:cNvPr>
           <p:cNvSpPr/>
           <p:nvPr/>
         </p:nvSpPr>
         <p:spPr>
           <a:xfrm>
-            <a:off x="3716148" y="2311920"/>
-            <a:ext cx="299336" cy="86042"/>
+            <a:off x="3467040" y="3214446"/>
+            <a:ext cx="1121208" cy="113398"/>
           </a:xfrm>
           <a:prstGeom prst="rect">
             <a:avLst/>
@@ -18597,16 +18621,16 @@
       </p:sp>
       <p:sp>
         <p:nvSpPr>
-          <p:cNvPr id="33" name="Invisible source link 5: https://www.komodohealth.com/product/marmot/">
-            <a:hlinkClick r:id="rId8"/>
+          <p:cNvPr id="36" name="Invisible source link 5: https://briya.com/aire-population-agent/">
+            <a:hlinkClick r:id="rId11"/>
           </p:cNvPr>
           <p:cNvSpPr/>
           <p:nvPr/>
         </p:nvSpPr>
         <p:spPr>
           <a:xfrm>
-            <a:off x="3900118" y="3032277"/>
-            <a:ext cx="426779" cy="84963"/>
+            <a:off x="3339241" y="3400920"/>
+            <a:ext cx="1312367" cy="113398"/>
           </a:xfrm>
           <a:prstGeom prst="rect">
             <a:avLst/>
@@ -18640,16 +18664,16 @@
       </p:sp>
       <p:sp>
         <p:nvSpPr>
-          <p:cNvPr id="34" name="Invisible source link 5: https://www.komodohealth.com/press/komodo-health-u">
-            <a:hlinkClick r:id="rId9"/>
+          <p:cNvPr id="9500" name="Invisible source link 6: https://business.optum.com/en/data-analytics/life-sciences/real-world-data/market-clarity-data.html">
+            <a:hlinkClick r:id="rId5"/>
           </p:cNvPr>
           <p:cNvSpPr/>
           <p:nvPr/>
         </p:nvSpPr>
         <p:spPr>
           <a:xfrm>
-            <a:off x="4602828" y="3032277"/>
-            <a:ext cx="346490" cy="108724"/>
+            <a:off x="8704795" y="2126095"/>
+            <a:ext cx="1088769" cy="134588"/>
           </a:xfrm>
           <a:prstGeom prst="rect">
             <a:avLst/>
@@ -18683,16 +18707,16 @@
       </p:sp>
       <p:sp>
         <p:nvSpPr>
-          <p:cNvPr id="35" name="Invisible source link 5: https://www.truveta.com/blog/announcement/truveta-">
-            <a:hlinkClick r:id="rId10"/>
+          <p:cNvPr id="9501" name="Invisible source link 6: https://business.optum.com/en/data-analytics/life-sciences/real-world-data/enriched-clinical-data.html">
+            <a:hlinkClick r:id="rId7"/>
           </p:cNvPr>
           <p:cNvSpPr/>
           <p:nvPr/>
         </p:nvSpPr>
         <p:spPr>
           <a:xfrm>
-            <a:off x="3467040" y="3214446"/>
-            <a:ext cx="1121208" cy="113398"/>
+            <a:off x="10951197" y="2126095"/>
+            <a:ext cx="513511" cy="134588"/>
           </a:xfrm>
           <a:prstGeom prst="rect">
             <a:avLst/>
@@ -18726,16 +18750,16 @@
       </p:sp>
       <p:sp>
         <p:nvSpPr>
-          <p:cNvPr id="36" name="Invisible source link 5: https://briya.com/aire-population-agent/">
-            <a:hlinkClick r:id="rId11"/>
+          <p:cNvPr id="9502" name="Invisible source link 6: https://business.optum.com/en/data-analytics/life-sciences/real-world-data/enriched-clinical-data.html">
+            <a:hlinkClick r:id="rId7"/>
           </p:cNvPr>
           <p:cNvSpPr/>
           <p:nvPr/>
         </p:nvSpPr>
         <p:spPr>
           <a:xfrm>
-            <a:off x="3339241" y="3400920"/>
-            <a:ext cx="1312367" cy="113398"/>
+            <a:off x="8704795" y="2261820"/>
+            <a:ext cx="721665" cy="134588"/>
           </a:xfrm>
           <a:prstGeom prst="rect">
             <a:avLst/>
@@ -18769,16 +18793,16 @@
       </p:sp>
       <p:sp>
         <p:nvSpPr>
-          <p:cNvPr id="40" name="Invisible source link 5: https://panalgo.com/ella/">
-            <a:hlinkClick r:id="rId15"/>
+          <p:cNvPr id="9503" name="Invisible source link 6: https://business.optum.com/en/data-analytics/life-sciences/heor/exploratory-analysis.html">
+            <a:hlinkClick r:id="rId12"/>
           </p:cNvPr>
           <p:cNvSpPr/>
           <p:nvPr/>
         </p:nvSpPr>
         <p:spPr>
           <a:xfrm>
-            <a:off x="3545157" y="4122001"/>
-            <a:ext cx="348649" cy="89280"/>
+            <a:off x="8704795" y="2989022"/>
+            <a:ext cx="1222996" cy="134588"/>
           </a:xfrm>
           <a:prstGeom prst="rect">
             <a:avLst/>
@@ -18812,16 +18836,16 @@
       </p:sp>
       <p:sp>
         <p:nvSpPr>
-          <p:cNvPr id="41" name="Invisible source link 5: https://www.bcplatforms.com/bc-catalyst">
-            <a:hlinkClick r:id="rId16"/>
+          <p:cNvPr id="9504" name="Invisible source link 6: https://business.optum.com/en/data-analytics/life-sciences/real-world-data/clinical-notes.html">
+            <a:hlinkClick r:id="rId13"/>
           </p:cNvPr>
           <p:cNvSpPr/>
           <p:nvPr/>
         </p:nvSpPr>
         <p:spPr>
           <a:xfrm>
-            <a:off x="3716872" y="4308487"/>
-            <a:ext cx="667975" cy="113398"/>
+            <a:off x="9198724" y="3124734"/>
+            <a:ext cx="1041856" cy="134588"/>
           </a:xfrm>
           <a:prstGeom prst="rect">
             <a:avLst/>
@@ -18855,16 +18879,16 @@
       </p:sp>
       <p:sp>
         <p:nvSpPr>
-          <p:cNvPr id="9500" name="Invisible source link 6: https://business.optum.com/en/data-analytics/life-sciences/real-world-data/market-clarity-data.html">
-            <a:hlinkClick r:id="rId5"/>
+          <p:cNvPr id="9505" name="Invisible source link 6: https://business.optum.com/en/data-analytics/life-sciences/clinical-trial-design.html">
+            <a:hlinkClick r:id="rId14"/>
           </p:cNvPr>
           <p:cNvSpPr/>
           <p:nvPr/>
         </p:nvSpPr>
         <p:spPr>
           <a:xfrm>
-            <a:off x="8704795" y="2126095"/>
-            <a:ext cx="1088769" cy="134588"/>
+            <a:off x="9198724" y="3260459"/>
+            <a:ext cx="634592" cy="134588"/>
           </a:xfrm>
           <a:prstGeom prst="rect">
             <a:avLst/>
@@ -18898,16 +18922,16 @@
       </p:sp>
       <p:sp>
         <p:nvSpPr>
-          <p:cNvPr id="9501" name="Invisible source link 6: https://business.optum.com/en/data-analytics/life-sciences/real-world-data/enriched-clinical-data.html">
-            <a:hlinkClick r:id="rId7"/>
+          <p:cNvPr id="9506" name="Invisible source link 6: https://business.optum.com/en/data-analytics/life-sciences/heor/exploratory-analysis.html">
+            <a:hlinkClick r:id="rId12"/>
           </p:cNvPr>
           <p:cNvSpPr/>
           <p:nvPr/>
         </p:nvSpPr>
         <p:spPr>
           <a:xfrm>
-            <a:off x="10951197" y="2126095"/>
-            <a:ext cx="513511" cy="134588"/>
+            <a:off x="8704795" y="4125901"/>
+            <a:ext cx="1222996" cy="134588"/>
           </a:xfrm>
           <a:prstGeom prst="rect">
             <a:avLst/>
@@ -18941,16 +18965,16 @@
       </p:sp>
       <p:sp>
         <p:nvSpPr>
-          <p:cNvPr id="9502" name="Invisible source link 6: https://business.optum.com/en/data-analytics/life-sciences/real-world-data/enriched-clinical-data.html">
-            <a:hlinkClick r:id="rId7"/>
+          <p:cNvPr id="9507" name="Invisible source link 6: https://business.optum.com/en/data-analytics/life-sciences/epidemiology-consulting.html">
+            <a:hlinkClick r:id="rId17"/>
           </p:cNvPr>
           <p:cNvSpPr/>
           <p:nvPr/>
         </p:nvSpPr>
         <p:spPr>
           <a:xfrm>
-            <a:off x="8704795" y="2261820"/>
-            <a:ext cx="721665" cy="134588"/>
+            <a:off x="9078125" y="4261613"/>
+            <a:ext cx="1823942" cy="134588"/>
           </a:xfrm>
           <a:prstGeom prst="rect">
             <a:avLst/>
@@ -18984,16 +19008,119 @@
       </p:sp>
       <p:sp>
         <p:nvSpPr>
-          <p:cNvPr id="9503" name="Invisible source link 6: https://business.optum.com/en/data-analytics/life-sciences/heor/exploratory-analysis.html">
-            <a:hlinkClick r:id="rId12"/>
+          <p:cNvPr id="9903" name="pre-engagement data evaluation card"/>
+          <p:cNvSpPr/>
+          <p:nvPr/>
+        </p:nvSpPr>
+        <p:spPr>
+          <a:xfrm>
+            <a:off x="6185916" y="5033010"/>
+            <a:ext cx="5454396" cy="1020318"/>
+          </a:xfrm>
+          <a:prstGeom prst="rect">
+            <a:avLst/>
+          </a:prstGeom>
+          <a:solidFill>
+            <a:schemeClr val="bg1"/>
+          </a:solidFill>
+          <a:ln/>
+          <a:effectLst>
+            <a:outerShdw sx="100000" sy="100000" kx="0" ky="0" algn="bl" rotWithShape="0" blurRad="101600" dist="25400" dir="5400000">
+              <a:srgbClr val="000000">
+                <a:alpha val="10000"/>
+              </a:srgbClr>
+            </a:outerShdw>
+          </a:effectLst>
+        </p:spPr>
+        <p:txBody>
+          <a:bodyPr/>
+          <a:p/>
+        </p:txBody>
+      </p:sp>
+      <p:sp>
+        <p:nvSpPr>
+          <p:cNvPr id="9904" name="label"/>
+          <p:cNvSpPr txBox="1"/>
+          <p:nvPr/>
+        </p:nvSpPr>
+        <p:spPr>
+          <a:xfrm>
+            <a:off x="6387084" y="5095113"/>
+            <a:ext cx="5052060" cy="256032"/>
+          </a:xfrm>
+          <a:prstGeom prst="rect">
+            <a:avLst/>
+          </a:prstGeom>
+          <a:noFill/>
+          <a:ln/>
+        </p:spPr>
+        <p:txBody>
+          <a:bodyPr wrap="square" lIns="0" tIns="0" rIns="0" bIns="0" rtlCol="0" anchor="t"/>
+          <a:lstStyle/>
+          <a:p>
+            <a:pPr indent="0" marL="0">
+              <a:buNone/>
+            </a:pPr>
+            <a:r>
+              <a:rPr lang="en-US" sz="1300" b="1" spc="150" kern="0" dirty="0">
+                <a:solidFill>
+                  <a:schemeClr val="accent2"/>
+                </a:solidFill>
+              </a:rPr>
+              <a:t>PRE-ENGAGEMENT DATA EVALUATION</a:t>
+            </a:r>
+            <a:endParaRPr lang="en-US" sz="1300" dirty="0"/>
+          </a:p>
+        </p:txBody>
+      </p:sp>
+      <p:sp>
+        <p:nvSpPr>
+          <p:cNvPr id="9905" name="Text 14"/>
+          <p:cNvSpPr txBox="1"/>
+          <p:nvPr/>
+        </p:nvSpPr>
+        <p:spPr>
+          <a:xfrm>
+            <a:off x="6387084" y="5424297"/>
+            <a:ext cx="5052060" cy="566928"/>
+          </a:xfrm>
+          <a:prstGeom prst="rect">
+            <a:avLst/>
+          </a:prstGeom>
+          <a:noFill/>
+          <a:ln/>
+        </p:spPr>
+        <p:txBody>
+          <a:bodyPr wrap="square" lIns="0" tIns="0" rIns="0" bIns="0" rtlCol="0" anchor="t"/>
+          <a:lstStyle/>
+          <a:p>
+            <a:pPr indent="0" marL="0">
+              <a:buNone/>
+            </a:pPr>
+            <a:r>
+              <a:rPr lang="en-US" sz="1050" b="1" dirty="0">
+                <a:solidFill>
+                  <a:schemeClr val="tx1"/>
+                </a:solidFill>
+              </a:rPr>
+              <a:t>MarketScan Snapshot uses conversational AI as a sales tool as well as an analytics feature, offering qualified prospects free AI access to cohort counts and summary statistics before they commit to a full RWE analysis.</a:t>
+            </a:r>
+            <a:endParaRPr lang="en-US" sz="1050" dirty="0"/>
+          </a:p>
+        </p:txBody>
+      </p:sp>
+      <p:sp>
+        <p:nvSpPr>
+          <p:cNvPr id="9732" name="Invisible source link 6: https://www.merative.com/newsroom/truven-launches-marketscan-snapshot-an-ai-powered-tool-to-evaluate-fit-for-purpose-real-world-data-in-minutes">
+            <a:hlinkClick r:id="rId3"/>
           </p:cNvPr>
           <p:cNvSpPr/>
           <p:nvPr/>
         </p:nvSpPr>
         <p:spPr>
           <a:xfrm>
-            <a:off x="8704795" y="2989022"/>
-            <a:ext cx="1222996" cy="134588"/>
+            <a:off x="3346564" y="2032852"/>
+            <a:ext cx="1290883" cy="134588"/>
           </a:xfrm>
           <a:prstGeom prst="rect">
             <a:avLst/>
@@ -19027,16 +19154,16 @@
       </p:sp>
       <p:sp>
         <p:nvSpPr>
-          <p:cNvPr id="9504" name="Invisible source link 6: https://business.optum.com/en/data-analytics/life-sciences/real-world-data/clinical-notes.html">
-            <a:hlinkClick r:id="rId13"/>
+          <p:cNvPr id="9734" name="Invisible source link 6: https://panalgo.com/ella/">
+            <a:hlinkClick r:id="rId15"/>
           </p:cNvPr>
           <p:cNvSpPr/>
           <p:nvPr/>
         </p:nvSpPr>
         <p:spPr>
           <a:xfrm>
-            <a:off x="9198724" y="3124734"/>
-            <a:ext cx="1041856" cy="134588"/>
+            <a:off x="3994200" y="2219339"/>
+            <a:ext cx="396283" cy="134588"/>
           </a:xfrm>
           <a:prstGeom prst="rect">
             <a:avLst/>
@@ -19070,16 +19197,16 @@
       </p:sp>
       <p:sp>
         <p:nvSpPr>
-          <p:cNvPr id="9505" name="Invisible source link 6: https://business.optum.com/en/data-analytics/life-sciences/clinical-trial-design.html">
-            <a:hlinkClick r:id="rId14"/>
+          <p:cNvPr id="9734" name="Invisible source link 6: https://healthverity.com/news/announcing-healthverity-exos/">
+            <a:hlinkClick r:id="rId4"/>
           </p:cNvPr>
           <p:cNvSpPr/>
           <p:nvPr/>
         </p:nvSpPr>
         <p:spPr>
           <a:xfrm>
-            <a:off x="9198724" y="3260459"/>
-            <a:ext cx="634592" cy="134588"/>
+            <a:off x="3625202" y="4100336"/>
+            <a:ext cx="341203" cy="134588"/>
           </a:xfrm>
           <a:prstGeom prst="rect">
             <a:avLst/>
@@ -19113,59 +19240,16 @@
       </p:sp>
       <p:sp>
         <p:nvSpPr>
-          <p:cNvPr id="9506" name="Invisible source link 6: https://business.optum.com/en/data-analytics/life-sciences/heor/exploratory-analysis.html">
-            <a:hlinkClick r:id="rId12"/>
+          <p:cNvPr id="9736" name="Invisible source link 6: https://www.bcplatforms.com/bc-catalyst">
+            <a:hlinkClick r:id="rId16"/>
           </p:cNvPr>
           <p:cNvSpPr/>
           <p:nvPr/>
         </p:nvSpPr>
         <p:spPr>
           <a:xfrm>
-            <a:off x="8704795" y="4125901"/>
-            <a:ext cx="1222996" cy="134588"/>
-          </a:xfrm>
-          <a:prstGeom prst="rect">
-            <a:avLst/>
-          </a:prstGeom>
-          <a:noFill/>
-          <a:ln>
-            <a:noFill/>
-          </a:ln>
-        </p:spPr>
-        <p:style>
-          <a:lnRef idx="1">
-            <a:schemeClr val="accent1"/>
-          </a:lnRef>
-          <a:fillRef idx="3">
-            <a:schemeClr val="accent1"/>
-          </a:fillRef>
-          <a:effectRef idx="2">
-            <a:schemeClr val="accent1"/>
-          </a:effectRef>
-          <a:fontRef idx="minor">
-            <a:schemeClr val="lt1"/>
-          </a:fontRef>
-        </p:style>
-        <p:txBody>
-          <a:bodyPr rtlCol="0" anchor="ctr"/>
-          <a:lstStyle/>
-          <a:p>
-            <a:pPr algn="ctr"/>
-          </a:p>
-        </p:txBody>
-      </p:sp>
-      <p:sp>
-        <p:nvSpPr>
-          <p:cNvPr id="9507" name="Invisible source link 6: https://business.optum.com/en/data-analytics/life-sciences/epidemiology-consulting.html">
-            <a:hlinkClick r:id="rId17"/>
-          </p:cNvPr>
-          <p:cNvSpPr/>
-          <p:nvPr/>
-        </p:nvSpPr>
-        <p:spPr>
-          <a:xfrm>
-            <a:off x="9078125" y="4261613"/>
-            <a:ext cx="1823942" cy="134588"/>
+            <a:off x="3707637" y="4286823"/>
+            <a:ext cx="674993" cy="134588"/>
           </a:xfrm>
           <a:prstGeom prst="rect">
             <a:avLst/>

</xml_diff>

<commit_message>
Revert page 10 content and layout; keep deck-wide link style and held changes
Co-Authored-By: Claude Opus 5.5 <noreply@anthropic.com>
Claude-Session: https://claude.ai/code/session_0198bm9pfzRwgZQBqNvd56W8
</commit_message>
<xml_diff>
--- a/deck/Optum-LS-Conversational-AI-sourced.pptx
+++ b/deck/Optum-LS-Conversational-AI-sourced.pptx
@@ -4004,7 +4004,7 @@
         </p:nvGraphicFramePr>
         <p:xfrm>
           <a:off x="548640" y="1755648"/>
-          <a:ext cx="11091672" cy="1448764"/>
+          <a:ext cx="11091672" cy="1587288"/>
         </p:xfrm>
         <a:graphic>
           <a:graphicData uri="http://schemas.openxmlformats.org/drawingml/2006/table">
@@ -4128,7 +4128,7 @@
                   </a:tcPr>
                 </a:tc>
               </a:tr>
-              <a:tr h="559790">
+              <a:tr h="608076">
                 <a:tc>
                   <a:txBody>
                     <a:bodyPr/>
@@ -4216,7 +4216,7 @@
                             </a:solidFill>
                           </a:uFill>
                         </a:rPr>
-                        <a:t>LIVE Conversational AI + Terrain</a:t>
+                        <a:t>Terrain AI Assistant</a:t>
                       </a:r>
                       <a:r>
                         <a:rPr lang="en-US" sz="950" dirty="0">
@@ -4224,7 +4224,7 @@
                             <a:schemeClr val="tx1"/>
                           </a:solidFill>
                         </a:rPr>
-                        <a:t>: Natural-language protocol feasibility, clinical-code generation and site/investigator intelligence</a:t>
+                        <a:t>: natural-language questions about trial sites, investigator experience and patient populations</a:t>
                       </a:r>
                       <a:endParaRPr lang="en-US" sz="950" dirty="0"/>
                     </a:p>
@@ -4333,7 +4333,7 @@
                   </a:tcPr>
                 </a:tc>
               </a:tr>
-              <a:tr h="559790">
+              <a:tr h="650028">
                 <a:tc>
                   <a:txBody>
                     <a:bodyPr/>
@@ -4553,7 +4553,7 @@
         </p:nvSpPr>
         <p:spPr>
           <a:xfrm>
-            <a:off x="548640" y="3350716"/>
+            <a:off x="548640" y="3489241"/>
             <a:ext cx="11091672" cy="201168"/>
           </a:xfrm>
           <a:prstGeom prst="rect">
@@ -4596,8 +4596,8 @@
           </p:nvPr>
         </p:nvGraphicFramePr>
         <p:xfrm>
-          <a:off x="548640" y="3625036"/>
-          <a:ext cx="11091672" cy="1024686"/>
+          <a:off x="548640" y="3763561"/>
+          <a:ext cx="11091672" cy="1226820"/>
         </p:xfrm>
         <a:graphic>
           <a:graphicData uri="http://schemas.openxmlformats.org/drawingml/2006/table">
@@ -4721,7 +4721,7 @@
                   </a:tcPr>
                 </a:tc>
               </a:tr>
-              <a:tr h="695502">
+              <a:tr h="897636">
                 <a:tc>
                   <a:txBody>
                     <a:bodyPr/>
@@ -4961,14 +4961,14 @@
       </p:graphicFrame>
       <p:sp>
         <p:nvSpPr>
-          <p:cNvPr id="18" name="live protocol testing card"/>
+          <p:cNvPr id="18" name="beyond the public evidence card"/>
           <p:cNvSpPr/>
           <p:nvPr/>
         </p:nvSpPr>
         <p:spPr>
           <a:xfrm>
-            <a:off x="2189988" y="4832604"/>
-            <a:ext cx="7808975" cy="1220724"/>
+            <a:off x="548640" y="5136685"/>
+            <a:ext cx="11091672" cy="971507"/>
           </a:xfrm>
           <a:prstGeom prst="rect">
             <a:avLst/>
@@ -4998,8 +4998,8 @@
         </p:nvSpPr>
         <p:spPr>
           <a:xfrm>
-            <a:off x="2391156" y="5015484"/>
-            <a:ext cx="7406640" cy="256032"/>
+            <a:off x="749808" y="5183526"/>
+            <a:ext cx="10689336" cy="256032"/>
           </a:xfrm>
           <a:prstGeom prst="rect">
             <a:avLst/>
@@ -5020,7 +5020,7 @@
                   <a:schemeClr val="accent2"/>
                 </a:solidFill>
               </a:rPr>
-              <a:t>LIVE PROTOCOL TESTING</a:t>
+              <a:t>BEYOND THE PUBLIC EVIDENCE</a:t>
             </a:r>
             <a:endParaRPr lang="en-US" sz="1300" dirty="0"/>
           </a:p>
@@ -5034,8 +5034,8 @@
         </p:nvSpPr>
         <p:spPr>
           <a:xfrm>
-            <a:off x="2391156" y="5362956"/>
-            <a:ext cx="7406640" cy="507491"/>
+            <a:off x="749808" y="5494422"/>
+            <a:ext cx="10689336" cy="566928"/>
           </a:xfrm>
           <a:prstGeom prst="rect">
             <a:avLst/>
@@ -5047,16 +5047,33 @@
           <a:bodyPr wrap="square" lIns="0" tIns="0" rIns="0" bIns="0" rtlCol="0" anchor="t"/>
           <a:lstStyle/>
           <a:p>
-            <a:pPr indent="0" marL="0" algn="just">
+            <a:pPr indent="0" marL="0">
               <a:buNone/>
             </a:pPr>
             <a:r>
-              <a:rPr lang="en-US" sz="1050" b="1" dirty="0">
+              <a:rPr lang="en-US" sz="1000" b="1" dirty="0">
                 <a:solidFill>
                   <a:schemeClr val="tx1"/>
                 </a:solidFill>
               </a:rPr>
-              <a:t>TriNetX says its LIVE conversational interface turns natural-language eligibility rules into editable clinical codes. In an October 2026 demonstration, adjusting one BMI exclusion criterion shifted a diabetes cohort by 27,000 patients instantly, “with no analyst required.” This makes feasibility a live input to protocol design.</a:t>
+              <a:t>For Clinical Trials, does the interface help identify viable sites, evaluate patients or manage trial documents—and how far does it go?</a:t>
+            </a:r>
+            <a:endParaRPr lang="en-US" sz="1050" dirty="0"/>
+          </a:p>
+          <a:p>
+            <a:pPr indent="0" marL="0">
+              <a:spcBef>
+                <a:spcPts val="600"/>
+              </a:spcBef>
+              <a:buNone/>
+            </a:pPr>
+            <a:r>
+              <a:rPr lang="en-US" sz="1000" b="1" dirty="0">
+                <a:solidFill>
+                  <a:schemeClr val="tx1"/>
+                </a:solidFill>
+              </a:rPr>
+              <a:t>For Market Access, is the customer asking for pricing intelligence, reimbursement information or new economic evidence? Where do the vendor offerings overlap with Optum LS, and where do they solve a different problem?</a:t>
             </a:r>
             <a:endParaRPr lang="en-US" sz="1050" dirty="0"/>
           </a:p>
@@ -5150,8 +5167,8 @@
         </p:nvSpPr>
         <p:spPr>
           <a:xfrm>
-            <a:off x="2944075" y="2229423"/>
-            <a:ext cx="2410845" cy="134588"/>
+            <a:off x="2944075" y="2253540"/>
+            <a:ext cx="1673204" cy="134588"/>
           </a:xfrm>
           <a:prstGeom prst="rect">
             <a:avLst/>
@@ -5193,7 +5210,7 @@
         </p:nvSpPr>
         <p:spPr>
           <a:xfrm>
-            <a:off x="2944075" y="2788858"/>
+            <a:off x="2944075" y="2882457"/>
             <a:ext cx="982622" cy="134588"/>
           </a:xfrm>
           <a:prstGeom prst="rect">
@@ -5236,7 +5253,7 @@
         </p:nvSpPr>
         <p:spPr>
           <a:xfrm>
-            <a:off x="2944075" y="4166579"/>
+            <a:off x="2944075" y="4405974"/>
             <a:ext cx="1490324" cy="134588"/>
           </a:xfrm>
           <a:prstGeom prst="rect">
@@ -5279,7 +5296,7 @@
         </p:nvSpPr>
         <p:spPr>
           <a:xfrm>
-            <a:off x="8704795" y="2161376"/>
+            <a:off x="8704795" y="2185862"/>
             <a:ext cx="634592" cy="134588"/>
           </a:xfrm>
           <a:prstGeom prst="rect">
@@ -5322,7 +5339,7 @@
         </p:nvSpPr>
         <p:spPr>
           <a:xfrm>
-            <a:off x="9198724" y="2297101"/>
+            <a:off x="9198724" y="2321574"/>
             <a:ext cx="1449602" cy="134588"/>
           </a:xfrm>
           <a:prstGeom prst="rect">
@@ -5365,7 +5382,7 @@
         </p:nvSpPr>
         <p:spPr>
           <a:xfrm>
-            <a:off x="8704795" y="2720811"/>
+            <a:off x="8704795" y="2814778"/>
             <a:ext cx="694168" cy="134588"/>
           </a:xfrm>
           <a:prstGeom prst="rect">
@@ -5408,7 +5425,7 @@
         </p:nvSpPr>
         <p:spPr>
           <a:xfrm>
-            <a:off x="8704795" y="4030854"/>
+            <a:off x="8704795" y="4270262"/>
             <a:ext cx="1182595" cy="134588"/>
           </a:xfrm>
           <a:prstGeom prst="rect">
@@ -5451,7 +5468,7 @@
         </p:nvSpPr>
         <p:spPr>
           <a:xfrm>
-            <a:off x="9794519" y="4166579"/>
+            <a:off x="9794519" y="4405974"/>
             <a:ext cx="962019" cy="134588"/>
           </a:xfrm>
           <a:prstGeom prst="rect">
@@ -5494,7 +5511,7 @@
         </p:nvSpPr>
         <p:spPr>
           <a:xfrm>
-            <a:off x="9815753" y="4302291"/>
+            <a:off x="9815753" y="4541699"/>
             <a:ext cx="1509781" cy="134588"/>
           </a:xfrm>
           <a:prstGeom prst="rect">
@@ -5537,7 +5554,7 @@
         </p:nvSpPr>
         <p:spPr>
           <a:xfrm>
-            <a:off x="8704795" y="4438016"/>
+            <a:off x="8704795" y="4677411"/>
             <a:ext cx="875429" cy="134588"/>
           </a:xfrm>
           <a:prstGeom prst="rect">
@@ -12213,7 +12230,7 @@
                   </a:solidFill>
                 </a:uFill>
               </a:rPr>
-              <a:t>TriNetX’s LIVE Conversational AI + Terrain</a:t>
+              <a:t>TriNetX’s Terrain AI Assistant</a:t>
             </a:r>
             <a:endParaRPr lang="en-US" sz="900" dirty="0"/>
           </a:p>
@@ -13457,7 +13474,7 @@
         <p:spPr>
           <a:xfrm>
             <a:off x="5806440" y="4445359"/>
-            <a:ext cx="2147260" cy="127757"/>
+            <a:ext cx="1464743" cy="127757"/>
           </a:xfrm>
           <a:prstGeom prst="rect">
             <a:avLst/>

</xml_diff>